<commit_message>
Update BI presentation with professional design
Co-authored-by: Loren292 <250579185+Loren292@users.noreply.github.com>
</commit_message>
<xml_diff>
--- a/Presentacion_BI.pptx
+++ b/Presentacion_BI.pptx
@@ -3086,7 +3086,7 @@
     <p:bg>
       <p:bgPr>
         <a:solidFill>
-          <a:srgbClr val="FFFFFF"/>
+          <a:srgbClr val="F5F7FA"/>
         </a:solidFill>
         <a:effectLst/>
       </p:bgPr>
@@ -3106,8 +3106,8 @@
         </p:nvSpPr>
         <p:spPr>
           <a:xfrm>
-            <a:off x="914400" y="2743200"/>
-            <a:ext cx="7315200" cy="1371600"/>
+            <a:off x="457200" y="457200"/>
+            <a:ext cx="8229600" cy="914400"/>
           </a:xfrm>
           <a:prstGeom prst="rect">
             <a:avLst/>
@@ -3115,21 +3115,284 @@
           <a:noFill/>
         </p:spPr>
         <p:txBody>
-          <a:bodyPr wrap="square">
+          <a:bodyPr wrap="none">
             <a:spAutoFit/>
           </a:bodyPr>
           <a:lstStyle/>
           <a:p>
-            <a:pPr algn="ctr">
-              <a:defRPr b="1" sz="2400">
+            <a:pPr>
+              <a:defRPr sz="2000" b="1">
                 <a:solidFill>
-                  <a:srgbClr val="000000"/>
+                  <a:srgbClr val="0072CE"/>
                 </a:solidFill>
-                <a:latin typeface="Arial"/>
+                <a:latin typeface="Segoe UI"/>
               </a:defRPr>
             </a:pPr>
             <a:r>
-              <a:t>DATOS TRANSACCIONALES CRUDOS   ➔   ⚙️   ➔   DECISIONES ESTRATÉGICAS RENTABLES</a:t>
+              <a:t>TRANSFORMACIÓN DE VALOR</a:t>
+            </a:r>
+          </a:p>
+        </p:txBody>
+      </p:sp>
+      <p:sp>
+        <p:nvSpPr>
+          <p:cNvPr id="3" name="Rounded Rectangle 2"/>
+          <p:cNvSpPr/>
+          <p:nvPr/>
+        </p:nvSpPr>
+        <p:spPr>
+          <a:xfrm>
+            <a:off x="457200" y="2743200"/>
+            <a:ext cx="2286000" cy="1371600"/>
+          </a:xfrm>
+          <a:prstGeom prst="roundRect">
+            <a:avLst/>
+          </a:prstGeom>
+          <a:solidFill>
+            <a:srgbClr val="0F2043"/>
+          </a:solidFill>
+          <a:ln>
+            <a:solidFill>
+              <a:srgbClr val="0F2043"/>
+            </a:solidFill>
+          </a:ln>
+        </p:spPr>
+        <p:style>
+          <a:lnRef idx="1">
+            <a:schemeClr val="accent1"/>
+          </a:lnRef>
+          <a:fillRef idx="3">
+            <a:schemeClr val="accent1"/>
+          </a:fillRef>
+          <a:effectRef idx="2">
+            <a:schemeClr val="accent1"/>
+          </a:effectRef>
+          <a:fontRef idx="minor">
+            <a:schemeClr val="lt1"/>
+          </a:fontRef>
+        </p:style>
+        <p:txBody>
+          <a:bodyPr rtlCol="0" anchor="ctr" wrap="square"/>
+          <a:lstStyle/>
+          <a:p>
+            <a:pPr algn="ctr">
+              <a:defRPr sz="2000" b="1">
+                <a:solidFill>
+                  <a:srgbClr val="FFFFFF"/>
+                </a:solidFill>
+                <a:latin typeface="Segoe UI"/>
+              </a:defRPr>
+            </a:pPr>
+            <a:r>
+              <a:t>DATOS</a:t>
+            </a:r>
+            <a:br/>
+            <a:r>
+              <a:t>CRUDOS</a:t>
+            </a:r>
+          </a:p>
+        </p:txBody>
+      </p:sp>
+      <p:sp>
+        <p:nvSpPr>
+          <p:cNvPr id="4" name="Right Arrow 3"/>
+          <p:cNvSpPr/>
+          <p:nvPr/>
+        </p:nvSpPr>
+        <p:spPr>
+          <a:xfrm>
+            <a:off x="2926080" y="3200400"/>
+            <a:ext cx="731520" cy="457200"/>
+          </a:xfrm>
+          <a:prstGeom prst="rightArrow">
+            <a:avLst/>
+          </a:prstGeom>
+          <a:solidFill>
+            <a:srgbClr val="0072CE"/>
+          </a:solidFill>
+          <a:ln>
+            <a:noFill/>
+          </a:ln>
+        </p:spPr>
+        <p:style>
+          <a:lnRef idx="1">
+            <a:schemeClr val="accent1"/>
+          </a:lnRef>
+          <a:fillRef idx="3">
+            <a:schemeClr val="accent1"/>
+          </a:fillRef>
+          <a:effectRef idx="2">
+            <a:schemeClr val="accent1"/>
+          </a:effectRef>
+          <a:fontRef idx="minor">
+            <a:schemeClr val="lt1"/>
+          </a:fontRef>
+        </p:style>
+        <p:txBody>
+          <a:bodyPr rtlCol="0" anchor="ctr"/>
+          <a:lstStyle/>
+          <a:p>
+            <a:pPr algn="ctr"/>
+          </a:p>
+        </p:txBody>
+      </p:sp>
+      <p:sp>
+        <p:nvSpPr>
+          <p:cNvPr id="5" name="Hexagon 4"/>
+          <p:cNvSpPr/>
+          <p:nvPr/>
+        </p:nvSpPr>
+        <p:spPr>
+          <a:xfrm>
+            <a:off x="3840480" y="2514600"/>
+            <a:ext cx="1828800" cy="1828800"/>
+          </a:xfrm>
+          <a:prstGeom prst="hexagon">
+            <a:avLst/>
+          </a:prstGeom>
+          <a:solidFill>
+            <a:srgbClr val="0072CE"/>
+          </a:solidFill>
+          <a:ln>
+            <a:solidFill>
+              <a:srgbClr val="0072CE"/>
+            </a:solidFill>
+          </a:ln>
+        </p:spPr>
+        <p:style>
+          <a:lnRef idx="1">
+            <a:schemeClr val="accent1"/>
+          </a:lnRef>
+          <a:fillRef idx="3">
+            <a:schemeClr val="accent1"/>
+          </a:fillRef>
+          <a:effectRef idx="2">
+            <a:schemeClr val="accent1"/>
+          </a:effectRef>
+          <a:fontRef idx="minor">
+            <a:schemeClr val="lt1"/>
+          </a:fontRef>
+        </p:style>
+        <p:txBody>
+          <a:bodyPr rtlCol="0" anchor="ctr" wrap="square"/>
+          <a:lstStyle/>
+          <a:p>
+            <a:pPr algn="ctr">
+              <a:defRPr sz="2200" b="1">
+                <a:solidFill>
+                  <a:srgbClr val="FFFFFF"/>
+                </a:solidFill>
+                <a:latin typeface="Segoe UI"/>
+              </a:defRPr>
+            </a:pPr>
+            <a:r>
+              <a:t>MOTOR</a:t>
+            </a:r>
+            <a:br/>
+            <a:r>
+              <a:t>B.I.</a:t>
+            </a:r>
+          </a:p>
+        </p:txBody>
+      </p:sp>
+      <p:sp>
+        <p:nvSpPr>
+          <p:cNvPr id="6" name="Right Arrow 5"/>
+          <p:cNvSpPr/>
+          <p:nvPr/>
+        </p:nvSpPr>
+        <p:spPr>
+          <a:xfrm>
+            <a:off x="5852160" y="3200400"/>
+            <a:ext cx="731520" cy="457200"/>
+          </a:xfrm>
+          <a:prstGeom prst="rightArrow">
+            <a:avLst/>
+          </a:prstGeom>
+          <a:solidFill>
+            <a:srgbClr val="0072CE"/>
+          </a:solidFill>
+          <a:ln>
+            <a:noFill/>
+          </a:ln>
+        </p:spPr>
+        <p:style>
+          <a:lnRef idx="1">
+            <a:schemeClr val="accent1"/>
+          </a:lnRef>
+          <a:fillRef idx="3">
+            <a:schemeClr val="accent1"/>
+          </a:fillRef>
+          <a:effectRef idx="2">
+            <a:schemeClr val="accent1"/>
+          </a:effectRef>
+          <a:fontRef idx="minor">
+            <a:schemeClr val="lt1"/>
+          </a:fontRef>
+        </p:style>
+        <p:txBody>
+          <a:bodyPr rtlCol="0" anchor="ctr"/>
+          <a:lstStyle/>
+          <a:p>
+            <a:pPr algn="ctr"/>
+          </a:p>
+        </p:txBody>
+      </p:sp>
+      <p:sp>
+        <p:nvSpPr>
+          <p:cNvPr id="7" name="Rounded Rectangle 6"/>
+          <p:cNvSpPr/>
+          <p:nvPr/>
+        </p:nvSpPr>
+        <p:spPr>
+          <a:xfrm>
+            <a:off x="6766560" y="2743200"/>
+            <a:ext cx="2286000" cy="1371600"/>
+          </a:xfrm>
+          <a:prstGeom prst="roundRect">
+            <a:avLst/>
+          </a:prstGeom>
+          <a:solidFill>
+            <a:srgbClr val="00B2A9"/>
+          </a:solidFill>
+          <a:ln>
+            <a:solidFill>
+              <a:srgbClr val="00B2A9"/>
+            </a:solidFill>
+          </a:ln>
+        </p:spPr>
+        <p:style>
+          <a:lnRef idx="1">
+            <a:schemeClr val="accent1"/>
+          </a:lnRef>
+          <a:fillRef idx="3">
+            <a:schemeClr val="accent1"/>
+          </a:fillRef>
+          <a:effectRef idx="2">
+            <a:schemeClr val="accent1"/>
+          </a:effectRef>
+          <a:fontRef idx="minor">
+            <a:schemeClr val="lt1"/>
+          </a:fontRef>
+        </p:style>
+        <p:txBody>
+          <a:bodyPr rtlCol="0" anchor="ctr" wrap="square"/>
+          <a:lstStyle/>
+          <a:p>
+            <a:pPr algn="ctr">
+              <a:defRPr sz="2000" b="1">
+                <a:solidFill>
+                  <a:srgbClr val="FFFFFF"/>
+                </a:solidFill>
+                <a:latin typeface="Segoe UI"/>
+              </a:defRPr>
+            </a:pPr>
+            <a:r>
+              <a:t>DECISIONES</a:t>
+            </a:r>
+            <a:br/>
+            <a:r>
+              <a:t>RENTABLES</a:t>
             </a:r>
           </a:p>
         </p:txBody>
@@ -3148,7 +3411,7 @@
     <p:bg>
       <p:bgPr>
         <a:solidFill>
-          <a:srgbClr val="FAFAFA"/>
+          <a:srgbClr val="F5F7FA"/>
         </a:solidFill>
         <a:effectLst/>
       </p:bgPr>
@@ -3162,14 +3425,119 @@
       <p:grpSpPr/>
       <p:sp>
         <p:nvSpPr>
-          <p:cNvPr id="2" name="TextBox 1"/>
+          <p:cNvPr id="2" name="Rectangle 1"/>
+          <p:cNvSpPr/>
+          <p:nvPr/>
+        </p:nvSpPr>
+        <p:spPr>
+          <a:xfrm>
+            <a:off x="0" y="0"/>
+            <a:ext cx="9144000" cy="1097280"/>
+          </a:xfrm>
+          <a:prstGeom prst="rect">
+            <a:avLst/>
+          </a:prstGeom>
+          <a:solidFill>
+            <a:srgbClr val="0F2043"/>
+          </a:solidFill>
+          <a:ln>
+            <a:noFill/>
+          </a:ln>
+        </p:spPr>
+        <p:style>
+          <a:lnRef idx="1">
+            <a:schemeClr val="accent1"/>
+          </a:lnRef>
+          <a:fillRef idx="3">
+            <a:schemeClr val="accent1"/>
+          </a:fillRef>
+          <a:effectRef idx="2">
+            <a:schemeClr val="accent1"/>
+          </a:effectRef>
+          <a:fontRef idx="minor">
+            <a:schemeClr val="lt1"/>
+          </a:fontRef>
+        </p:style>
+        <p:txBody>
+          <a:bodyPr rtlCol="0" anchor="ctr"/>
+          <a:lstStyle/>
+          <a:p>
+            <a:pPr algn="ctr">
+              <a:defRPr b="1" sz="3200">
+                <a:solidFill>
+                  <a:srgbClr val="FFFFFF"/>
+                </a:solidFill>
+                <a:latin typeface="Segoe UI"/>
+              </a:defRPr>
+            </a:pPr>
+            <a:r>
+              <a:t>ESTRUCTURA METODOLÓGICA</a:t>
+            </a:r>
+          </a:p>
+        </p:txBody>
+      </p:sp>
+      <p:sp>
+        <p:nvSpPr>
+          <p:cNvPr id="3" name="Oval 2"/>
+          <p:cNvSpPr/>
+          <p:nvPr/>
+        </p:nvSpPr>
+        <p:spPr>
+          <a:xfrm>
+            <a:off x="457200" y="1645920"/>
+            <a:ext cx="640080" cy="640080"/>
+          </a:xfrm>
+          <a:prstGeom prst="ellipse">
+            <a:avLst/>
+          </a:prstGeom>
+          <a:solidFill>
+            <a:srgbClr val="0072CE"/>
+          </a:solidFill>
+          <a:ln>
+            <a:noFill/>
+          </a:ln>
+        </p:spPr>
+        <p:style>
+          <a:lnRef idx="1">
+            <a:schemeClr val="accent1"/>
+          </a:lnRef>
+          <a:fillRef idx="3">
+            <a:schemeClr val="accent1"/>
+          </a:fillRef>
+          <a:effectRef idx="2">
+            <a:schemeClr val="accent1"/>
+          </a:effectRef>
+          <a:fontRef idx="minor">
+            <a:schemeClr val="lt1"/>
+          </a:fontRef>
+        </p:style>
+        <p:txBody>
+          <a:bodyPr rtlCol="0" anchor="ctr"/>
+          <a:lstStyle/>
+          <a:p>
+            <a:pPr algn="ctr">
+              <a:defRPr b="1" sz="2000">
+                <a:solidFill>
+                  <a:srgbClr val="FFFFFF"/>
+                </a:solidFill>
+              </a:defRPr>
+            </a:pPr>
+            <a:r>
+              <a:t>01</a:t>
+            </a:r>
+          </a:p>
+        </p:txBody>
+      </p:sp>
+      <p:sp>
+        <p:nvSpPr>
+          <p:cNvPr id="4" name="TextBox 3"/>
           <p:cNvSpPr txBox="1"/>
           <p:nvPr/>
         </p:nvSpPr>
         <p:spPr>
           <a:xfrm>
-            <a:off x="914400" y="457200"/>
-            <a:ext cx="7315200" cy="914400"/>
+            <a:off x="1280160" y="1645920"/>
+            <a:ext cx="2286000" cy="640080"/>
           </a:xfrm>
           <a:prstGeom prst="rect">
             <a:avLst/>
@@ -3182,27 +3550,30 @@
           </a:bodyPr>
           <a:lstStyle/>
           <a:p>
-            <a:pPr algn="ctr">
-              <a:defRPr b="1" sz="3600">
-                <a:latin typeface="Arial"/>
+            <a:pPr>
+              <a:defRPr b="1" sz="1800">
+                <a:solidFill>
+                  <a:srgbClr val="0F2043"/>
+                </a:solidFill>
+                <a:latin typeface="Segoe UI"/>
               </a:defRPr>
             </a:pPr>
             <a:r>
-              <a:t>ESTRUCTURA METODOLÓGICA</a:t>
-            </a:r>
-          </a:p>
-        </p:txBody>
-      </p:sp>
-      <p:sp>
-        <p:nvSpPr>
-          <p:cNvPr id="3" name="TextBox 2"/>
+              <a:t>DIAGNÓSTICO</a:t>
+            </a:r>
+          </a:p>
+        </p:txBody>
+      </p:sp>
+      <p:sp>
+        <p:nvSpPr>
+          <p:cNvPr id="5" name="TextBox 4"/>
           <p:cNvSpPr txBox="1"/>
           <p:nvPr/>
         </p:nvSpPr>
         <p:spPr>
           <a:xfrm>
-            <a:off x="1371600" y="1828800"/>
-            <a:ext cx="6400800" cy="4114800"/>
+            <a:off x="3657600" y="1645920"/>
+            <a:ext cx="5029200" cy="640080"/>
           </a:xfrm>
           <a:prstGeom prst="rect">
             <a:avLst/>
@@ -3210,85 +3581,517 @@
           <a:noFill/>
         </p:spPr>
         <p:txBody>
-          <a:bodyPr wrap="square">
+          <a:bodyPr wrap="none">
             <a:spAutoFit/>
           </a:bodyPr>
           <a:lstStyle/>
           <a:p>
             <a:pPr>
-              <a:defRPr sz="2400">
+              <a:defRPr sz="1600">
                 <a:solidFill>
-                  <a:srgbClr val="323232"/>
+                  <a:srgbClr val="333333"/>
                 </a:solidFill>
-                <a:latin typeface="Arial"/>
+                <a:latin typeface="Segoe UI"/>
               </a:defRPr>
             </a:pPr>
             <a:r>
-              <a:t>1. Diagnóstico: Auditoría de bases de datos y mapeo de procesos.</a:t>
-            </a:r>
-          </a:p>
-          <a:p>
-            <a:pPr>
-              <a:spcBef>
-                <a:spcPts val="1400"/>
-              </a:spcBef>
-              <a:defRPr sz="2400">
+              <a:t>Auditoría de bases de datos y mapeo de procesos.</a:t>
+            </a:r>
+          </a:p>
+        </p:txBody>
+      </p:sp>
+      <p:sp>
+        <p:nvSpPr>
+          <p:cNvPr id="6" name="Oval 5"/>
+          <p:cNvSpPr/>
+          <p:nvPr/>
+        </p:nvSpPr>
+        <p:spPr>
+          <a:xfrm>
+            <a:off x="457200" y="2468880"/>
+            <a:ext cx="640080" cy="640080"/>
+          </a:xfrm>
+          <a:prstGeom prst="ellipse">
+            <a:avLst/>
+          </a:prstGeom>
+          <a:solidFill>
+            <a:srgbClr val="0072CE"/>
+          </a:solidFill>
+          <a:ln>
+            <a:noFill/>
+          </a:ln>
+        </p:spPr>
+        <p:style>
+          <a:lnRef idx="1">
+            <a:schemeClr val="accent1"/>
+          </a:lnRef>
+          <a:fillRef idx="3">
+            <a:schemeClr val="accent1"/>
+          </a:fillRef>
+          <a:effectRef idx="2">
+            <a:schemeClr val="accent1"/>
+          </a:effectRef>
+          <a:fontRef idx="minor">
+            <a:schemeClr val="lt1"/>
+          </a:fontRef>
+        </p:style>
+        <p:txBody>
+          <a:bodyPr rtlCol="0" anchor="ctr"/>
+          <a:lstStyle/>
+          <a:p>
+            <a:pPr algn="ctr">
+              <a:defRPr b="1" sz="2000">
                 <a:solidFill>
-                  <a:srgbClr val="323232"/>
+                  <a:srgbClr val="FFFFFF"/>
                 </a:solidFill>
-                <a:latin typeface="Arial"/>
               </a:defRPr>
             </a:pPr>
             <a:r>
-              <a:t>2. Estructuración: Diseño dimensional y proceso ETL.</a:t>
-            </a:r>
-          </a:p>
+              <a:t>02</a:t>
+            </a:r>
+          </a:p>
+        </p:txBody>
+      </p:sp>
+      <p:sp>
+        <p:nvSpPr>
+          <p:cNvPr id="7" name="TextBox 6"/>
+          <p:cNvSpPr txBox="1"/>
+          <p:nvPr/>
+        </p:nvSpPr>
+        <p:spPr>
+          <a:xfrm>
+            <a:off x="1280160" y="2468880"/>
+            <a:ext cx="2286000" cy="640080"/>
+          </a:xfrm>
+          <a:prstGeom prst="rect">
+            <a:avLst/>
+          </a:prstGeom>
+          <a:noFill/>
+        </p:spPr>
+        <p:txBody>
+          <a:bodyPr wrap="none">
+            <a:spAutoFit/>
+          </a:bodyPr>
+          <a:lstStyle/>
           <a:p>
             <a:pPr>
-              <a:spcBef>
-                <a:spcPts val="1400"/>
-              </a:spcBef>
-              <a:defRPr sz="2400">
+              <a:defRPr b="1" sz="1800">
                 <a:solidFill>
-                  <a:srgbClr val="323232"/>
+                  <a:srgbClr val="0F2043"/>
                 </a:solidFill>
-                <a:latin typeface="Arial"/>
+                <a:latin typeface="Segoe UI"/>
               </a:defRPr>
             </a:pPr>
             <a:r>
-              <a:t>3. Formulación: Modelado matemático de KPIs operativos.</a:t>
-            </a:r>
-          </a:p>
+              <a:t>ESTRUCTURACIÓN</a:t>
+            </a:r>
+          </a:p>
+        </p:txBody>
+      </p:sp>
+      <p:sp>
+        <p:nvSpPr>
+          <p:cNvPr id="8" name="TextBox 7"/>
+          <p:cNvSpPr txBox="1"/>
+          <p:nvPr/>
+        </p:nvSpPr>
+        <p:spPr>
+          <a:xfrm>
+            <a:off x="3657600" y="2468880"/>
+            <a:ext cx="5029200" cy="640080"/>
+          </a:xfrm>
+          <a:prstGeom prst="rect">
+            <a:avLst/>
+          </a:prstGeom>
+          <a:noFill/>
+        </p:spPr>
+        <p:txBody>
+          <a:bodyPr wrap="none">
+            <a:spAutoFit/>
+          </a:bodyPr>
+          <a:lstStyle/>
           <a:p>
             <a:pPr>
-              <a:spcBef>
-                <a:spcPts val="1400"/>
-              </a:spcBef>
-              <a:defRPr sz="2400">
+              <a:defRPr sz="1600">
                 <a:solidFill>
-                  <a:srgbClr val="323232"/>
+                  <a:srgbClr val="333333"/>
                 </a:solidFill>
-                <a:latin typeface="Arial"/>
+                <a:latin typeface="Segoe UI"/>
               </a:defRPr>
             </a:pPr>
             <a:r>
-              <a:t>4. Desarrollo Visual: Tablero de Control interactivo (BI).</a:t>
-            </a:r>
-          </a:p>
-          <a:p>
-            <a:pPr>
-              <a:spcBef>
-                <a:spcPts val="1400"/>
-              </a:spcBef>
-              <a:defRPr sz="2400">
+              <a:t>Diseño dimensional y pipeline ETL sin código.</a:t>
+            </a:r>
+          </a:p>
+        </p:txBody>
+      </p:sp>
+      <p:sp>
+        <p:nvSpPr>
+          <p:cNvPr id="9" name="Oval 8"/>
+          <p:cNvSpPr/>
+          <p:nvPr/>
+        </p:nvSpPr>
+        <p:spPr>
+          <a:xfrm>
+            <a:off x="457200" y="3291840"/>
+            <a:ext cx="640080" cy="640080"/>
+          </a:xfrm>
+          <a:prstGeom prst="ellipse">
+            <a:avLst/>
+          </a:prstGeom>
+          <a:solidFill>
+            <a:srgbClr val="0072CE"/>
+          </a:solidFill>
+          <a:ln>
+            <a:noFill/>
+          </a:ln>
+        </p:spPr>
+        <p:style>
+          <a:lnRef idx="1">
+            <a:schemeClr val="accent1"/>
+          </a:lnRef>
+          <a:fillRef idx="3">
+            <a:schemeClr val="accent1"/>
+          </a:fillRef>
+          <a:effectRef idx="2">
+            <a:schemeClr val="accent1"/>
+          </a:effectRef>
+          <a:fontRef idx="minor">
+            <a:schemeClr val="lt1"/>
+          </a:fontRef>
+        </p:style>
+        <p:txBody>
+          <a:bodyPr rtlCol="0" anchor="ctr"/>
+          <a:lstStyle/>
+          <a:p>
+            <a:pPr algn="ctr">
+              <a:defRPr b="1" sz="2000">
                 <a:solidFill>
-                  <a:srgbClr val="323232"/>
+                  <a:srgbClr val="FFFFFF"/>
                 </a:solidFill>
-                <a:latin typeface="Arial"/>
               </a:defRPr>
             </a:pPr>
             <a:r>
-              <a:t>5. Evaluación Económica: Viabilidad financiera (VAN y TIR).</a:t>
+              <a:t>03</a:t>
+            </a:r>
+          </a:p>
+        </p:txBody>
+      </p:sp>
+      <p:sp>
+        <p:nvSpPr>
+          <p:cNvPr id="10" name="TextBox 9"/>
+          <p:cNvSpPr txBox="1"/>
+          <p:nvPr/>
+        </p:nvSpPr>
+        <p:spPr>
+          <a:xfrm>
+            <a:off x="1280160" y="3291840"/>
+            <a:ext cx="2286000" cy="640080"/>
+          </a:xfrm>
+          <a:prstGeom prst="rect">
+            <a:avLst/>
+          </a:prstGeom>
+          <a:noFill/>
+        </p:spPr>
+        <p:txBody>
+          <a:bodyPr wrap="none">
+            <a:spAutoFit/>
+          </a:bodyPr>
+          <a:lstStyle/>
+          <a:p>
+            <a:pPr>
+              <a:defRPr b="1" sz="1800">
+                <a:solidFill>
+                  <a:srgbClr val="0F2043"/>
+                </a:solidFill>
+                <a:latin typeface="Segoe UI"/>
+              </a:defRPr>
+            </a:pPr>
+            <a:r>
+              <a:t>FORMULACIÓN</a:t>
+            </a:r>
+          </a:p>
+        </p:txBody>
+      </p:sp>
+      <p:sp>
+        <p:nvSpPr>
+          <p:cNvPr id="11" name="TextBox 10"/>
+          <p:cNvSpPr txBox="1"/>
+          <p:nvPr/>
+        </p:nvSpPr>
+        <p:spPr>
+          <a:xfrm>
+            <a:off x="3657600" y="3291840"/>
+            <a:ext cx="5029200" cy="640080"/>
+          </a:xfrm>
+          <a:prstGeom prst="rect">
+            <a:avLst/>
+          </a:prstGeom>
+          <a:noFill/>
+        </p:spPr>
+        <p:txBody>
+          <a:bodyPr wrap="none">
+            <a:spAutoFit/>
+          </a:bodyPr>
+          <a:lstStyle/>
+          <a:p>
+            <a:pPr>
+              <a:defRPr sz="1600">
+                <a:solidFill>
+                  <a:srgbClr val="333333"/>
+                </a:solidFill>
+                <a:latin typeface="Segoe UI"/>
+              </a:defRPr>
+            </a:pPr>
+            <a:r>
+              <a:t>Modelado matemático de KPIs operativos y financieros.</a:t>
+            </a:r>
+          </a:p>
+        </p:txBody>
+      </p:sp>
+      <p:sp>
+        <p:nvSpPr>
+          <p:cNvPr id="12" name="Oval 11"/>
+          <p:cNvSpPr/>
+          <p:nvPr/>
+        </p:nvSpPr>
+        <p:spPr>
+          <a:xfrm>
+            <a:off x="457200" y="4114800"/>
+            <a:ext cx="640080" cy="640080"/>
+          </a:xfrm>
+          <a:prstGeom prst="ellipse">
+            <a:avLst/>
+          </a:prstGeom>
+          <a:solidFill>
+            <a:srgbClr val="0072CE"/>
+          </a:solidFill>
+          <a:ln>
+            <a:noFill/>
+          </a:ln>
+        </p:spPr>
+        <p:style>
+          <a:lnRef idx="1">
+            <a:schemeClr val="accent1"/>
+          </a:lnRef>
+          <a:fillRef idx="3">
+            <a:schemeClr val="accent1"/>
+          </a:fillRef>
+          <a:effectRef idx="2">
+            <a:schemeClr val="accent1"/>
+          </a:effectRef>
+          <a:fontRef idx="minor">
+            <a:schemeClr val="lt1"/>
+          </a:fontRef>
+        </p:style>
+        <p:txBody>
+          <a:bodyPr rtlCol="0" anchor="ctr"/>
+          <a:lstStyle/>
+          <a:p>
+            <a:pPr algn="ctr">
+              <a:defRPr b="1" sz="2000">
+                <a:solidFill>
+                  <a:srgbClr val="FFFFFF"/>
+                </a:solidFill>
+              </a:defRPr>
+            </a:pPr>
+            <a:r>
+              <a:t>04</a:t>
+            </a:r>
+          </a:p>
+        </p:txBody>
+      </p:sp>
+      <p:sp>
+        <p:nvSpPr>
+          <p:cNvPr id="13" name="TextBox 12"/>
+          <p:cNvSpPr txBox="1"/>
+          <p:nvPr/>
+        </p:nvSpPr>
+        <p:spPr>
+          <a:xfrm>
+            <a:off x="1280160" y="4114800"/>
+            <a:ext cx="2286000" cy="640080"/>
+          </a:xfrm>
+          <a:prstGeom prst="rect">
+            <a:avLst/>
+          </a:prstGeom>
+          <a:noFill/>
+        </p:spPr>
+        <p:txBody>
+          <a:bodyPr wrap="none">
+            <a:spAutoFit/>
+          </a:bodyPr>
+          <a:lstStyle/>
+          <a:p>
+            <a:pPr>
+              <a:defRPr b="1" sz="1800">
+                <a:solidFill>
+                  <a:srgbClr val="0F2043"/>
+                </a:solidFill>
+                <a:latin typeface="Segoe UI"/>
+              </a:defRPr>
+            </a:pPr>
+            <a:r>
+              <a:t>DESARROLLO</a:t>
+            </a:r>
+          </a:p>
+        </p:txBody>
+      </p:sp>
+      <p:sp>
+        <p:nvSpPr>
+          <p:cNvPr id="14" name="TextBox 13"/>
+          <p:cNvSpPr txBox="1"/>
+          <p:nvPr/>
+        </p:nvSpPr>
+        <p:spPr>
+          <a:xfrm>
+            <a:off x="3657600" y="4114800"/>
+            <a:ext cx="5029200" cy="640080"/>
+          </a:xfrm>
+          <a:prstGeom prst="rect">
+            <a:avLst/>
+          </a:prstGeom>
+          <a:noFill/>
+        </p:spPr>
+        <p:txBody>
+          <a:bodyPr wrap="none">
+            <a:spAutoFit/>
+          </a:bodyPr>
+          <a:lstStyle/>
+          <a:p>
+            <a:pPr>
+              <a:defRPr sz="1600">
+                <a:solidFill>
+                  <a:srgbClr val="333333"/>
+                </a:solidFill>
+                <a:latin typeface="Segoe UI"/>
+              </a:defRPr>
+            </a:pPr>
+            <a:r>
+              <a:t>Despliegue del Tablero de Control interactivo.</a:t>
+            </a:r>
+          </a:p>
+        </p:txBody>
+      </p:sp>
+      <p:sp>
+        <p:nvSpPr>
+          <p:cNvPr id="15" name="Oval 14"/>
+          <p:cNvSpPr/>
+          <p:nvPr/>
+        </p:nvSpPr>
+        <p:spPr>
+          <a:xfrm>
+            <a:off x="457200" y="4937760"/>
+            <a:ext cx="640080" cy="640080"/>
+          </a:xfrm>
+          <a:prstGeom prst="ellipse">
+            <a:avLst/>
+          </a:prstGeom>
+          <a:solidFill>
+            <a:srgbClr val="0072CE"/>
+          </a:solidFill>
+          <a:ln>
+            <a:noFill/>
+          </a:ln>
+        </p:spPr>
+        <p:style>
+          <a:lnRef idx="1">
+            <a:schemeClr val="accent1"/>
+          </a:lnRef>
+          <a:fillRef idx="3">
+            <a:schemeClr val="accent1"/>
+          </a:fillRef>
+          <a:effectRef idx="2">
+            <a:schemeClr val="accent1"/>
+          </a:effectRef>
+          <a:fontRef idx="minor">
+            <a:schemeClr val="lt1"/>
+          </a:fontRef>
+        </p:style>
+        <p:txBody>
+          <a:bodyPr rtlCol="0" anchor="ctr"/>
+          <a:lstStyle/>
+          <a:p>
+            <a:pPr algn="ctr">
+              <a:defRPr b="1" sz="2000">
+                <a:solidFill>
+                  <a:srgbClr val="FFFFFF"/>
+                </a:solidFill>
+              </a:defRPr>
+            </a:pPr>
+            <a:r>
+              <a:t>05</a:t>
+            </a:r>
+          </a:p>
+        </p:txBody>
+      </p:sp>
+      <p:sp>
+        <p:nvSpPr>
+          <p:cNvPr id="16" name="TextBox 15"/>
+          <p:cNvSpPr txBox="1"/>
+          <p:nvPr/>
+        </p:nvSpPr>
+        <p:spPr>
+          <a:xfrm>
+            <a:off x="1280160" y="4937760"/>
+            <a:ext cx="2286000" cy="640080"/>
+          </a:xfrm>
+          <a:prstGeom prst="rect">
+            <a:avLst/>
+          </a:prstGeom>
+          <a:noFill/>
+        </p:spPr>
+        <p:txBody>
+          <a:bodyPr wrap="none">
+            <a:spAutoFit/>
+          </a:bodyPr>
+          <a:lstStyle/>
+          <a:p>
+            <a:pPr>
+              <a:defRPr b="1" sz="1800">
+                <a:solidFill>
+                  <a:srgbClr val="0F2043"/>
+                </a:solidFill>
+                <a:latin typeface="Segoe UI"/>
+              </a:defRPr>
+            </a:pPr>
+            <a:r>
+              <a:t>EVALUACIÓN</a:t>
+            </a:r>
+          </a:p>
+        </p:txBody>
+      </p:sp>
+      <p:sp>
+        <p:nvSpPr>
+          <p:cNvPr id="17" name="TextBox 16"/>
+          <p:cNvSpPr txBox="1"/>
+          <p:nvPr/>
+        </p:nvSpPr>
+        <p:spPr>
+          <a:xfrm>
+            <a:off x="3657600" y="4937760"/>
+            <a:ext cx="5029200" cy="640080"/>
+          </a:xfrm>
+          <a:prstGeom prst="rect">
+            <a:avLst/>
+          </a:prstGeom>
+          <a:noFill/>
+        </p:spPr>
+        <p:txBody>
+          <a:bodyPr wrap="none">
+            <a:spAutoFit/>
+          </a:bodyPr>
+          <a:lstStyle/>
+          <a:p>
+            <a:pPr>
+              <a:defRPr sz="1600">
+                <a:solidFill>
+                  <a:srgbClr val="333333"/>
+                </a:solidFill>
+                <a:latin typeface="Segoe UI"/>
+              </a:defRPr>
+            </a:pPr>
+            <a:r>
+              <a:t>Análisis de viabilidad económica (VAN, TIR y ROI).</a:t>
             </a:r>
           </a:p>
         </p:txBody>
@@ -3307,7 +4110,7 @@
     <p:bg>
       <p:bgPr>
         <a:solidFill>
-          <a:srgbClr val="0A193C"/>
+          <a:srgbClr val="0F2043"/>
         </a:solidFill>
         <a:effectLst/>
       </p:bgPr>
@@ -3327,7 +4130,7 @@
         </p:nvSpPr>
         <p:spPr>
           <a:xfrm>
-            <a:off x="914400" y="914400"/>
+            <a:off x="914400" y="731520"/>
             <a:ext cx="7315200" cy="914400"/>
           </a:xfrm>
           <a:prstGeom prst="rect">
@@ -3342,11 +4145,11 @@
           <a:lstStyle/>
           <a:p>
             <a:pPr algn="ctr">
-              <a:defRPr b="1" sz="4000">
+              <a:defRPr b="1" sz="3600">
                 <a:solidFill>
                   <a:srgbClr val="FFFFFF"/>
                 </a:solidFill>
-                <a:latin typeface="Arial"/>
+                <a:latin typeface="Segoe UI"/>
               </a:defRPr>
             </a:pPr>
             <a:r>
@@ -3357,14 +4160,100 @@
       </p:sp>
       <p:sp>
         <p:nvSpPr>
-          <p:cNvPr id="3" name="TextBox 2"/>
+          <p:cNvPr id="3" name="Rounded Rectangle 2"/>
+          <p:cNvSpPr/>
+          <p:nvPr/>
+        </p:nvSpPr>
+        <p:spPr>
+          <a:xfrm>
+            <a:off x="914400" y="2286000"/>
+            <a:ext cx="2286000" cy="3200400"/>
+          </a:xfrm>
+          <a:prstGeom prst="roundRect">
+            <a:avLst/>
+          </a:prstGeom>
+          <a:solidFill>
+            <a:srgbClr val="FFFFFF"/>
+          </a:solidFill>
+          <a:ln>
+            <a:noFill/>
+          </a:ln>
+        </p:spPr>
+        <p:style>
+          <a:lnRef idx="1">
+            <a:schemeClr val="accent1"/>
+          </a:lnRef>
+          <a:fillRef idx="3">
+            <a:schemeClr val="accent1"/>
+          </a:fillRef>
+          <a:effectRef idx="2">
+            <a:schemeClr val="accent1"/>
+          </a:effectRef>
+          <a:fontRef idx="minor">
+            <a:schemeClr val="lt1"/>
+          </a:fontRef>
+        </p:style>
+        <p:txBody>
+          <a:bodyPr rtlCol="0" anchor="ctr"/>
+          <a:lstStyle/>
+          <a:p>
+            <a:pPr algn="ctr"/>
+          </a:p>
+        </p:txBody>
+      </p:sp>
+      <p:sp>
+        <p:nvSpPr>
+          <p:cNvPr id="4" name="Rectangle 3"/>
+          <p:cNvSpPr/>
+          <p:nvPr/>
+        </p:nvSpPr>
+        <p:spPr>
+          <a:xfrm>
+            <a:off x="914400" y="2286000"/>
+            <a:ext cx="2286000" cy="182880"/>
+          </a:xfrm>
+          <a:prstGeom prst="rect">
+            <a:avLst/>
+          </a:prstGeom>
+          <a:solidFill>
+            <a:srgbClr val="00B2A9"/>
+          </a:solidFill>
+          <a:ln>
+            <a:noFill/>
+          </a:ln>
+        </p:spPr>
+        <p:style>
+          <a:lnRef idx="1">
+            <a:schemeClr val="accent1"/>
+          </a:lnRef>
+          <a:fillRef idx="3">
+            <a:schemeClr val="accent1"/>
+          </a:fillRef>
+          <a:effectRef idx="2">
+            <a:schemeClr val="accent1"/>
+          </a:effectRef>
+          <a:fontRef idx="minor">
+            <a:schemeClr val="lt1"/>
+          </a:fontRef>
+        </p:style>
+        <p:txBody>
+          <a:bodyPr rtlCol="0" anchor="ctr"/>
+          <a:lstStyle/>
+          <a:p>
+            <a:pPr algn="ctr"/>
+          </a:p>
+        </p:txBody>
+      </p:sp>
+      <p:sp>
+        <p:nvSpPr>
+          <p:cNvPr id="5" name="TextBox 4"/>
           <p:cNvSpPr txBox="1"/>
           <p:nvPr/>
         </p:nvSpPr>
         <p:spPr>
           <a:xfrm>
-            <a:off x="1371600" y="2743200"/>
-            <a:ext cx="6400800" cy="2743200"/>
+            <a:off x="914400" y="2743200"/>
+            <a:ext cx="2286000" cy="914400"/>
           </a:xfrm>
           <a:prstGeom prst="rect">
             <a:avLst/>
@@ -3372,53 +4261,373 @@
           <a:noFill/>
         </p:spPr>
         <p:txBody>
+          <a:bodyPr wrap="none">
+            <a:spAutoFit/>
+          </a:bodyPr>
+          <a:lstStyle/>
+          <a:p>
+            <a:pPr algn="ctr">
+              <a:defRPr b="1" sz="4000">
+                <a:solidFill>
+                  <a:srgbClr val="DCE1EB"/>
+                </a:solidFill>
+                <a:latin typeface="Segoe UI"/>
+              </a:defRPr>
+            </a:pPr>
+            <a:r>
+              <a:t>01</a:t>
+            </a:r>
+          </a:p>
+        </p:txBody>
+      </p:sp>
+      <p:sp>
+        <p:nvSpPr>
+          <p:cNvPr id="6" name="TextBox 5"/>
+          <p:cNvSpPr txBox="1"/>
+          <p:nvPr/>
+        </p:nvSpPr>
+        <p:spPr>
+          <a:xfrm>
+            <a:off x="1005840" y="3657600"/>
+            <a:ext cx="2103120" cy="1371600"/>
+          </a:xfrm>
+          <a:prstGeom prst="rect">
+            <a:avLst/>
+          </a:prstGeom>
+          <a:noFill/>
+        </p:spPr>
+        <p:txBody>
           <a:bodyPr wrap="square">
             <a:spAutoFit/>
           </a:bodyPr>
           <a:lstStyle/>
           <a:p>
             <a:pPr algn="ctr">
-              <a:defRPr b="1" sz="2800">
+              <a:defRPr b="1" sz="2000">
                 <a:solidFill>
-                  <a:srgbClr val="FFFFFF"/>
+                  <a:srgbClr val="0F2043"/>
                 </a:solidFill>
-                <a:latin typeface="Arial"/>
+                <a:latin typeface="Segoe UI"/>
               </a:defRPr>
             </a:pPr>
             <a:r>
-              <a:t>I. Arquitectura de Datos Saneada</a:t>
-            </a:r>
-          </a:p>
+              <a:t>Arquitectura de Datos Saneada</a:t>
+            </a:r>
+          </a:p>
+        </p:txBody>
+      </p:sp>
+      <p:sp>
+        <p:nvSpPr>
+          <p:cNvPr id="7" name="Rounded Rectangle 6"/>
+          <p:cNvSpPr/>
+          <p:nvPr/>
+        </p:nvSpPr>
+        <p:spPr>
+          <a:xfrm>
+            <a:off x="3657600" y="2286000"/>
+            <a:ext cx="2286000" cy="3200400"/>
+          </a:xfrm>
+          <a:prstGeom prst="roundRect">
+            <a:avLst/>
+          </a:prstGeom>
+          <a:solidFill>
+            <a:srgbClr val="FFFFFF"/>
+          </a:solidFill>
+          <a:ln>
+            <a:noFill/>
+          </a:ln>
+        </p:spPr>
+        <p:style>
+          <a:lnRef idx="1">
+            <a:schemeClr val="accent1"/>
+          </a:lnRef>
+          <a:fillRef idx="3">
+            <a:schemeClr val="accent1"/>
+          </a:fillRef>
+          <a:effectRef idx="2">
+            <a:schemeClr val="accent1"/>
+          </a:effectRef>
+          <a:fontRef idx="minor">
+            <a:schemeClr val="lt1"/>
+          </a:fontRef>
+        </p:style>
+        <p:txBody>
+          <a:bodyPr rtlCol="0" anchor="ctr"/>
+          <a:lstStyle/>
+          <a:p>
+            <a:pPr algn="ctr"/>
+          </a:p>
+        </p:txBody>
+      </p:sp>
+      <p:sp>
+        <p:nvSpPr>
+          <p:cNvPr id="8" name="Rectangle 7"/>
+          <p:cNvSpPr/>
+          <p:nvPr/>
+        </p:nvSpPr>
+        <p:spPr>
+          <a:xfrm>
+            <a:off x="3657600" y="2286000"/>
+            <a:ext cx="2286000" cy="182880"/>
+          </a:xfrm>
+          <a:prstGeom prst="rect">
+            <a:avLst/>
+          </a:prstGeom>
+          <a:solidFill>
+            <a:srgbClr val="00B2A9"/>
+          </a:solidFill>
+          <a:ln>
+            <a:noFill/>
+          </a:ln>
+        </p:spPr>
+        <p:style>
+          <a:lnRef idx="1">
+            <a:schemeClr val="accent1"/>
+          </a:lnRef>
+          <a:fillRef idx="3">
+            <a:schemeClr val="accent1"/>
+          </a:fillRef>
+          <a:effectRef idx="2">
+            <a:schemeClr val="accent1"/>
+          </a:effectRef>
+          <a:fontRef idx="minor">
+            <a:schemeClr val="lt1"/>
+          </a:fontRef>
+        </p:style>
+        <p:txBody>
+          <a:bodyPr rtlCol="0" anchor="ctr"/>
+          <a:lstStyle/>
+          <a:p>
+            <a:pPr algn="ctr"/>
+          </a:p>
+        </p:txBody>
+      </p:sp>
+      <p:sp>
+        <p:nvSpPr>
+          <p:cNvPr id="9" name="TextBox 8"/>
+          <p:cNvSpPr txBox="1"/>
+          <p:nvPr/>
+        </p:nvSpPr>
+        <p:spPr>
+          <a:xfrm>
+            <a:off x="3657600" y="2743200"/>
+            <a:ext cx="2286000" cy="914400"/>
+          </a:xfrm>
+          <a:prstGeom prst="rect">
+            <a:avLst/>
+          </a:prstGeom>
+          <a:noFill/>
+        </p:spPr>
+        <p:txBody>
+          <a:bodyPr wrap="none">
+            <a:spAutoFit/>
+          </a:bodyPr>
+          <a:lstStyle/>
           <a:p>
             <a:pPr algn="ctr">
-              <a:spcBef>
-                <a:spcPts val="3000"/>
-              </a:spcBef>
-              <a:defRPr b="1" sz="2800">
+              <a:defRPr b="1" sz="4000">
                 <a:solidFill>
-                  <a:srgbClr val="FFFFFF"/>
+                  <a:srgbClr val="DCE1EB"/>
                 </a:solidFill>
-                <a:latin typeface="Arial"/>
+                <a:latin typeface="Segoe UI"/>
               </a:defRPr>
             </a:pPr>
             <a:r>
-              <a:t>II. Motor de KPIs Operativos</a:t>
-            </a:r>
-          </a:p>
+              <a:t>02</a:t>
+            </a:r>
+          </a:p>
+        </p:txBody>
+      </p:sp>
+      <p:sp>
+        <p:nvSpPr>
+          <p:cNvPr id="10" name="TextBox 9"/>
+          <p:cNvSpPr txBox="1"/>
+          <p:nvPr/>
+        </p:nvSpPr>
+        <p:spPr>
+          <a:xfrm>
+            <a:off x="3749039" y="3657600"/>
+            <a:ext cx="2103120" cy="1371600"/>
+          </a:xfrm>
+          <a:prstGeom prst="rect">
+            <a:avLst/>
+          </a:prstGeom>
+          <a:noFill/>
+        </p:spPr>
+        <p:txBody>
+          <a:bodyPr wrap="square">
+            <a:spAutoFit/>
+          </a:bodyPr>
+          <a:lstStyle/>
           <a:p>
             <a:pPr algn="ctr">
-              <a:spcBef>
-                <a:spcPts val="3000"/>
-              </a:spcBef>
-              <a:defRPr b="1" sz="2800">
+              <a:defRPr b="1" sz="2000">
                 <a:solidFill>
-                  <a:srgbClr val="FFFFFF"/>
+                  <a:srgbClr val="0F2043"/>
                 </a:solidFill>
-                <a:latin typeface="Arial"/>
+                <a:latin typeface="Segoe UI"/>
               </a:defRPr>
             </a:pPr>
             <a:r>
-              <a:t>III. Viabilidad Financiera Demostrada</a:t>
+              <a:t>Motor de KPIs Operativos</a:t>
+            </a:r>
+          </a:p>
+        </p:txBody>
+      </p:sp>
+      <p:sp>
+        <p:nvSpPr>
+          <p:cNvPr id="11" name="Rounded Rectangle 10"/>
+          <p:cNvSpPr/>
+          <p:nvPr/>
+        </p:nvSpPr>
+        <p:spPr>
+          <a:xfrm>
+            <a:off x="6400800" y="2286000"/>
+            <a:ext cx="2286000" cy="3200400"/>
+          </a:xfrm>
+          <a:prstGeom prst="roundRect">
+            <a:avLst/>
+          </a:prstGeom>
+          <a:solidFill>
+            <a:srgbClr val="FFFFFF"/>
+          </a:solidFill>
+          <a:ln>
+            <a:noFill/>
+          </a:ln>
+        </p:spPr>
+        <p:style>
+          <a:lnRef idx="1">
+            <a:schemeClr val="accent1"/>
+          </a:lnRef>
+          <a:fillRef idx="3">
+            <a:schemeClr val="accent1"/>
+          </a:fillRef>
+          <a:effectRef idx="2">
+            <a:schemeClr val="accent1"/>
+          </a:effectRef>
+          <a:fontRef idx="minor">
+            <a:schemeClr val="lt1"/>
+          </a:fontRef>
+        </p:style>
+        <p:txBody>
+          <a:bodyPr rtlCol="0" anchor="ctr"/>
+          <a:lstStyle/>
+          <a:p>
+            <a:pPr algn="ctr"/>
+          </a:p>
+        </p:txBody>
+      </p:sp>
+      <p:sp>
+        <p:nvSpPr>
+          <p:cNvPr id="12" name="Rectangle 11"/>
+          <p:cNvSpPr/>
+          <p:nvPr/>
+        </p:nvSpPr>
+        <p:spPr>
+          <a:xfrm>
+            <a:off x="6400800" y="2286000"/>
+            <a:ext cx="2286000" cy="182880"/>
+          </a:xfrm>
+          <a:prstGeom prst="rect">
+            <a:avLst/>
+          </a:prstGeom>
+          <a:solidFill>
+            <a:srgbClr val="00B2A9"/>
+          </a:solidFill>
+          <a:ln>
+            <a:noFill/>
+          </a:ln>
+        </p:spPr>
+        <p:style>
+          <a:lnRef idx="1">
+            <a:schemeClr val="accent1"/>
+          </a:lnRef>
+          <a:fillRef idx="3">
+            <a:schemeClr val="accent1"/>
+          </a:fillRef>
+          <a:effectRef idx="2">
+            <a:schemeClr val="accent1"/>
+          </a:effectRef>
+          <a:fontRef idx="minor">
+            <a:schemeClr val="lt1"/>
+          </a:fontRef>
+        </p:style>
+        <p:txBody>
+          <a:bodyPr rtlCol="0" anchor="ctr"/>
+          <a:lstStyle/>
+          <a:p>
+            <a:pPr algn="ctr"/>
+          </a:p>
+        </p:txBody>
+      </p:sp>
+      <p:sp>
+        <p:nvSpPr>
+          <p:cNvPr id="13" name="TextBox 12"/>
+          <p:cNvSpPr txBox="1"/>
+          <p:nvPr/>
+        </p:nvSpPr>
+        <p:spPr>
+          <a:xfrm>
+            <a:off x="6400800" y="2743200"/>
+            <a:ext cx="2286000" cy="914400"/>
+          </a:xfrm>
+          <a:prstGeom prst="rect">
+            <a:avLst/>
+          </a:prstGeom>
+          <a:noFill/>
+        </p:spPr>
+        <p:txBody>
+          <a:bodyPr wrap="none">
+            <a:spAutoFit/>
+          </a:bodyPr>
+          <a:lstStyle/>
+          <a:p>
+            <a:pPr algn="ctr">
+              <a:defRPr b="1" sz="4000">
+                <a:solidFill>
+                  <a:srgbClr val="DCE1EB"/>
+                </a:solidFill>
+                <a:latin typeface="Segoe UI"/>
+              </a:defRPr>
+            </a:pPr>
+            <a:r>
+              <a:t>03</a:t>
+            </a:r>
+          </a:p>
+        </p:txBody>
+      </p:sp>
+      <p:sp>
+        <p:nvSpPr>
+          <p:cNvPr id="14" name="TextBox 13"/>
+          <p:cNvSpPr txBox="1"/>
+          <p:nvPr/>
+        </p:nvSpPr>
+        <p:spPr>
+          <a:xfrm>
+            <a:off x="6492240" y="3657600"/>
+            <a:ext cx="2103120" cy="1371600"/>
+          </a:xfrm>
+          <a:prstGeom prst="rect">
+            <a:avLst/>
+          </a:prstGeom>
+          <a:noFill/>
+        </p:spPr>
+        <p:txBody>
+          <a:bodyPr wrap="square">
+            <a:spAutoFit/>
+          </a:bodyPr>
+          <a:lstStyle/>
+          <a:p>
+            <a:pPr algn="ctr">
+              <a:defRPr b="1" sz="2000">
+                <a:solidFill>
+                  <a:srgbClr val="0F2043"/>
+                </a:solidFill>
+                <a:latin typeface="Segoe UI"/>
+              </a:defRPr>
+            </a:pPr>
+            <a:r>
+              <a:t>Viabilidad Financiera Demostrada</a:t>
             </a:r>
           </a:p>
         </p:txBody>

</xml_diff>

<commit_message>
Update BI presentation with dark mode and background image
Co-authored-by: Loren292 <250579185+Loren292@users.noreply.github.com>
</commit_message>
<xml_diff>
--- a/Presentacion_BI.pptx
+++ b/Presentacion_BI.pptx
@@ -3083,14 +3083,6 @@
 <file path=ppt/slides/slide1.xml><?xml version="1.0" encoding="utf-8"?>
 <p:sld xmlns:a="http://schemas.openxmlformats.org/drawingml/2006/main" xmlns:p="http://schemas.openxmlformats.org/presentationml/2006/main" xmlns:r="http://schemas.openxmlformats.org/officeDocument/2006/relationships">
   <p:cSld>
-    <p:bg>
-      <p:bgPr>
-        <a:solidFill>
-          <a:srgbClr val="F5F7FA"/>
-        </a:solidFill>
-        <a:effectLst/>
-      </p:bgPr>
-    </p:bg>
     <p:spTree>
       <p:nvGrpSpPr>
         <p:cNvPr id="1" name=""/>
@@ -3098,9 +3090,33 @@
         <p:nvPr/>
       </p:nvGrpSpPr>
       <p:grpSpPr/>
-      <p:sp>
-        <p:nvSpPr>
-          <p:cNvPr id="2" name="TextBox 1"/>
+      <p:pic>
+        <p:nvPicPr>
+          <p:cNvPr id="2" name="Picture 1" descr="dark_bg.jpg"/>
+          <p:cNvPicPr>
+            <a:picLocks noChangeAspect="1"/>
+          </p:cNvPicPr>
+          <p:nvPr/>
+        </p:nvPicPr>
+        <p:blipFill>
+          <a:blip r:embed="rId2"/>
+          <a:stretch>
+            <a:fillRect/>
+          </a:stretch>
+        </p:blipFill>
+        <p:spPr>
+          <a:xfrm>
+            <a:off x="0" y="0"/>
+            <a:ext cx="9144000" cy="6858000"/>
+          </a:xfrm>
+          <a:prstGeom prst="rect">
+            <a:avLst/>
+          </a:prstGeom>
+        </p:spPr>
+      </p:pic>
+      <p:sp>
+        <p:nvSpPr>
+          <p:cNvPr id="3" name="TextBox 2"/>
           <p:cNvSpPr txBox="1"/>
           <p:nvPr/>
         </p:nvSpPr>
@@ -3121,9 +3137,9 @@
           <a:lstStyle/>
           <a:p>
             <a:pPr>
-              <a:defRPr sz="2000" b="1">
+              <a:defRPr sz="2200" b="1">
                 <a:solidFill>
-                  <a:srgbClr val="0072CE"/>
+                  <a:srgbClr val="00D2FF"/>
                 </a:solidFill>
                 <a:latin typeface="Segoe UI"/>
               </a:defRPr>
@@ -3136,7 +3152,7 @@
       </p:sp>
       <p:sp>
         <p:nvSpPr>
-          <p:cNvPr id="3" name="Rounded Rectangle 2"/>
+          <p:cNvPr id="4" name="Rounded Rectangle 3"/>
           <p:cNvSpPr/>
           <p:nvPr/>
         </p:nvSpPr>
@@ -3149,11 +3165,11 @@
             <a:avLst/>
           </a:prstGeom>
           <a:solidFill>
-            <a:srgbClr val="0F2043"/>
+            <a:srgbClr val="141419"/>
           </a:solidFill>
           <a:ln>
             <a:solidFill>
-              <a:srgbClr val="0F2043"/>
+              <a:srgbClr val="AAAAB4"/>
             </a:solidFill>
           </a:ln>
         </p:spPr>
@@ -3178,7 +3194,7 @@
             <a:pPr algn="ctr">
               <a:defRPr sz="2000" b="1">
                 <a:solidFill>
-                  <a:srgbClr val="FFFFFF"/>
+                  <a:srgbClr val="F0F0F0"/>
                 </a:solidFill>
                 <a:latin typeface="Segoe UI"/>
               </a:defRPr>
@@ -3195,7 +3211,7 @@
       </p:sp>
       <p:sp>
         <p:nvSpPr>
-          <p:cNvPr id="4" name="Right Arrow 3"/>
+          <p:cNvPr id="5" name="Right Arrow 4"/>
           <p:cNvSpPr/>
           <p:nvPr/>
         </p:nvSpPr>
@@ -3208,7 +3224,7 @@
             <a:avLst/>
           </a:prstGeom>
           <a:solidFill>
-            <a:srgbClr val="0072CE"/>
+            <a:srgbClr val="8A2BE2"/>
           </a:solidFill>
           <a:ln>
             <a:noFill/>
@@ -3238,7 +3254,7 @@
       </p:sp>
       <p:sp>
         <p:nvSpPr>
-          <p:cNvPr id="5" name="Hexagon 4"/>
+          <p:cNvPr id="6" name="Hexagon 5"/>
           <p:cNvSpPr/>
           <p:nvPr/>
         </p:nvSpPr>
@@ -3251,11 +3267,11 @@
             <a:avLst/>
           </a:prstGeom>
           <a:solidFill>
-            <a:srgbClr val="0072CE"/>
+            <a:srgbClr val="8A2BE2"/>
           </a:solidFill>
           <a:ln>
             <a:solidFill>
-              <a:srgbClr val="0072CE"/>
+              <a:srgbClr val="8A2BE2"/>
             </a:solidFill>
           </a:ln>
         </p:spPr>
@@ -3280,7 +3296,7 @@
             <a:pPr algn="ctr">
               <a:defRPr sz="2200" b="1">
                 <a:solidFill>
-                  <a:srgbClr val="FFFFFF"/>
+                  <a:srgbClr val="F0F0F0"/>
                 </a:solidFill>
                 <a:latin typeface="Segoe UI"/>
               </a:defRPr>
@@ -3297,7 +3313,7 @@
       </p:sp>
       <p:sp>
         <p:nvSpPr>
-          <p:cNvPr id="6" name="Right Arrow 5"/>
+          <p:cNvPr id="7" name="Right Arrow 6"/>
           <p:cNvSpPr/>
           <p:nvPr/>
         </p:nvSpPr>
@@ -3310,7 +3326,7 @@
             <a:avLst/>
           </a:prstGeom>
           <a:solidFill>
-            <a:srgbClr val="0072CE"/>
+            <a:srgbClr val="00D2FF"/>
           </a:solidFill>
           <a:ln>
             <a:noFill/>
@@ -3340,7 +3356,7 @@
       </p:sp>
       <p:sp>
         <p:nvSpPr>
-          <p:cNvPr id="7" name="Rounded Rectangle 6"/>
+          <p:cNvPr id="8" name="Rounded Rectangle 7"/>
           <p:cNvSpPr/>
           <p:nvPr/>
         </p:nvSpPr>
@@ -3353,11 +3369,11 @@
             <a:avLst/>
           </a:prstGeom>
           <a:solidFill>
-            <a:srgbClr val="00B2A9"/>
+            <a:srgbClr val="141419"/>
           </a:solidFill>
           <a:ln>
             <a:solidFill>
-              <a:srgbClr val="00B2A9"/>
+              <a:srgbClr val="00D2FF"/>
             </a:solidFill>
           </a:ln>
         </p:spPr>
@@ -3382,7 +3398,7 @@
             <a:pPr algn="ctr">
               <a:defRPr sz="2000" b="1">
                 <a:solidFill>
-                  <a:srgbClr val="FFFFFF"/>
+                  <a:srgbClr val="F0F0F0"/>
                 </a:solidFill>
                 <a:latin typeface="Segoe UI"/>
               </a:defRPr>
@@ -3408,14 +3424,6 @@
 <file path=ppt/slides/slide2.xml><?xml version="1.0" encoding="utf-8"?>
 <p:sld xmlns:a="http://schemas.openxmlformats.org/drawingml/2006/main" xmlns:p="http://schemas.openxmlformats.org/presentationml/2006/main" xmlns:r="http://schemas.openxmlformats.org/officeDocument/2006/relationships">
   <p:cSld>
-    <p:bg>
-      <p:bgPr>
-        <a:solidFill>
-          <a:srgbClr val="F5F7FA"/>
-        </a:solidFill>
-        <a:effectLst/>
-      </p:bgPr>
-    </p:bg>
     <p:spTree>
       <p:nvGrpSpPr>
         <p:cNvPr id="1" name=""/>
@@ -3423,22 +3431,82 @@
         <p:nvPr/>
       </p:nvGrpSpPr>
       <p:grpSpPr/>
-      <p:sp>
-        <p:nvSpPr>
-          <p:cNvPr id="2" name="Rectangle 1"/>
+      <p:pic>
+        <p:nvPicPr>
+          <p:cNvPr id="2" name="Picture 1" descr="dark_bg.jpg"/>
+          <p:cNvPicPr>
+            <a:picLocks noChangeAspect="1"/>
+          </p:cNvPicPr>
+          <p:nvPr/>
+        </p:nvPicPr>
+        <p:blipFill>
+          <a:blip r:embed="rId2"/>
+          <a:stretch>
+            <a:fillRect/>
+          </a:stretch>
+        </p:blipFill>
+        <p:spPr>
+          <a:xfrm>
+            <a:off x="0" y="0"/>
+            <a:ext cx="9144000" cy="6858000"/>
+          </a:xfrm>
+          <a:prstGeom prst="rect">
+            <a:avLst/>
+          </a:prstGeom>
+        </p:spPr>
+      </p:pic>
+      <p:sp>
+        <p:nvSpPr>
+          <p:cNvPr id="3" name="TextBox 2"/>
+          <p:cNvSpPr txBox="1"/>
+          <p:nvPr/>
+        </p:nvSpPr>
+        <p:spPr>
+          <a:xfrm>
+            <a:off x="457200" y="457200"/>
+            <a:ext cx="8229600" cy="1097280"/>
+          </a:xfrm>
+          <a:prstGeom prst="rect">
+            <a:avLst/>
+          </a:prstGeom>
+          <a:noFill/>
+        </p:spPr>
+        <p:txBody>
+          <a:bodyPr wrap="none">
+            <a:spAutoFit/>
+          </a:bodyPr>
+          <a:lstStyle/>
+          <a:p>
+            <a:pPr>
+              <a:defRPr b="1" sz="3600">
+                <a:solidFill>
+                  <a:srgbClr val="F0F0F0"/>
+                </a:solidFill>
+                <a:latin typeface="Segoe UI"/>
+              </a:defRPr>
+            </a:pPr>
+            <a:r>
+              <a:t>ESTRUCTURA METODOLÓGICA</a:t>
+            </a:r>
+          </a:p>
+        </p:txBody>
+      </p:sp>
+      <p:sp>
+        <p:nvSpPr>
+          <p:cNvPr id="4" name="Rectangle 3"/>
           <p:cNvSpPr/>
           <p:nvPr/>
         </p:nvSpPr>
         <p:spPr>
           <a:xfrm>
-            <a:off x="0" y="0"/>
-            <a:ext cx="9144000" cy="1097280"/>
+            <a:off x="457200" y="1371600"/>
+            <a:ext cx="1828800" cy="45720"/>
           </a:xfrm>
           <a:prstGeom prst="rect">
             <a:avLst/>
           </a:prstGeom>
           <a:solidFill>
-            <a:srgbClr val="0F2043"/>
+            <a:srgbClr val="00D2FF"/>
           </a:solidFill>
           <a:ln>
             <a:noFill/>
@@ -3462,36 +3530,26 @@
           <a:bodyPr rtlCol="0" anchor="ctr"/>
           <a:lstStyle/>
           <a:p>
-            <a:pPr algn="ctr">
-              <a:defRPr b="1" sz="3200">
-                <a:solidFill>
-                  <a:srgbClr val="FFFFFF"/>
-                </a:solidFill>
-                <a:latin typeface="Segoe UI"/>
-              </a:defRPr>
-            </a:pPr>
-            <a:r>
-              <a:t>ESTRUCTURA METODOLÓGICA</a:t>
-            </a:r>
-          </a:p>
-        </p:txBody>
-      </p:sp>
-      <p:sp>
-        <p:nvSpPr>
-          <p:cNvPr id="3" name="Oval 2"/>
+            <a:pPr algn="ctr"/>
+          </a:p>
+        </p:txBody>
+      </p:sp>
+      <p:sp>
+        <p:nvSpPr>
+          <p:cNvPr id="5" name="Oval 4"/>
           <p:cNvSpPr/>
           <p:nvPr/>
         </p:nvSpPr>
         <p:spPr>
           <a:xfrm>
-            <a:off x="457200" y="1645920"/>
-            <a:ext cx="640080" cy="640080"/>
+            <a:off x="457200" y="1828800"/>
+            <a:ext cx="548640" cy="548640"/>
           </a:xfrm>
           <a:prstGeom prst="ellipse">
             <a:avLst/>
           </a:prstGeom>
           <a:solidFill>
-            <a:srgbClr val="0072CE"/>
+            <a:srgbClr val="8A2BE2"/>
           </a:solidFill>
           <a:ln>
             <a:noFill/>
@@ -3516,9 +3574,9 @@
           <a:lstStyle/>
           <a:p>
             <a:pPr algn="ctr">
-              <a:defRPr b="1" sz="2000">
+              <a:defRPr b="1" sz="1600">
                 <a:solidFill>
-                  <a:srgbClr val="FFFFFF"/>
+                  <a:srgbClr val="F0F0F0"/>
                 </a:solidFill>
               </a:defRPr>
             </a:pPr>
@@ -3530,14 +3588,14 @@
       </p:sp>
       <p:sp>
         <p:nvSpPr>
-          <p:cNvPr id="4" name="TextBox 3"/>
+          <p:cNvPr id="6" name="TextBox 5"/>
           <p:cNvSpPr txBox="1"/>
           <p:nvPr/>
         </p:nvSpPr>
         <p:spPr>
           <a:xfrm>
-            <a:off x="1280160" y="1645920"/>
-            <a:ext cx="2286000" cy="640080"/>
+            <a:off x="1188720" y="1737360"/>
+            <a:ext cx="2743200" cy="457200"/>
           </a:xfrm>
           <a:prstGeom prst="rect">
             <a:avLst/>
@@ -3553,7 +3611,7 @@
             <a:pPr>
               <a:defRPr b="1" sz="1800">
                 <a:solidFill>
-                  <a:srgbClr val="0F2043"/>
+                  <a:srgbClr val="00D2FF"/>
                 </a:solidFill>
                 <a:latin typeface="Segoe UI"/>
               </a:defRPr>
@@ -3566,14 +3624,14 @@
       </p:sp>
       <p:sp>
         <p:nvSpPr>
-          <p:cNvPr id="5" name="TextBox 4"/>
+          <p:cNvPr id="7" name="TextBox 6"/>
           <p:cNvSpPr txBox="1"/>
           <p:nvPr/>
         </p:nvSpPr>
         <p:spPr>
           <a:xfrm>
-            <a:off x="3657600" y="1645920"/>
-            <a:ext cx="5029200" cy="640080"/>
+            <a:off x="1188720" y="2103120"/>
+            <a:ext cx="7315200" cy="457200"/>
           </a:xfrm>
           <a:prstGeom prst="rect">
             <a:avLst/>
@@ -3589,7 +3647,7 @@
             <a:pPr>
               <a:defRPr sz="1600">
                 <a:solidFill>
-                  <a:srgbClr val="333333"/>
+                  <a:srgbClr val="AAAAB4"/>
                 </a:solidFill>
                 <a:latin typeface="Segoe UI"/>
               </a:defRPr>
@@ -3602,20 +3660,20 @@
       </p:sp>
       <p:sp>
         <p:nvSpPr>
-          <p:cNvPr id="6" name="Oval 5"/>
+          <p:cNvPr id="8" name="Oval 7"/>
           <p:cNvSpPr/>
           <p:nvPr/>
         </p:nvSpPr>
         <p:spPr>
           <a:xfrm>
-            <a:off x="457200" y="2468880"/>
-            <a:ext cx="640080" cy="640080"/>
+            <a:off x="457200" y="2743200"/>
+            <a:ext cx="548640" cy="548640"/>
           </a:xfrm>
           <a:prstGeom prst="ellipse">
             <a:avLst/>
           </a:prstGeom>
           <a:solidFill>
-            <a:srgbClr val="0072CE"/>
+            <a:srgbClr val="8A2BE2"/>
           </a:solidFill>
           <a:ln>
             <a:noFill/>
@@ -3640,9 +3698,9 @@
           <a:lstStyle/>
           <a:p>
             <a:pPr algn="ctr">
-              <a:defRPr b="1" sz="2000">
+              <a:defRPr b="1" sz="1600">
                 <a:solidFill>
-                  <a:srgbClr val="FFFFFF"/>
+                  <a:srgbClr val="F0F0F0"/>
                 </a:solidFill>
               </a:defRPr>
             </a:pPr>
@@ -3654,14 +3712,14 @@
       </p:sp>
       <p:sp>
         <p:nvSpPr>
-          <p:cNvPr id="7" name="TextBox 6"/>
+          <p:cNvPr id="9" name="TextBox 8"/>
           <p:cNvSpPr txBox="1"/>
           <p:nvPr/>
         </p:nvSpPr>
         <p:spPr>
           <a:xfrm>
-            <a:off x="1280160" y="2468880"/>
-            <a:ext cx="2286000" cy="640080"/>
+            <a:off x="1188720" y="2651760"/>
+            <a:ext cx="2743200" cy="457200"/>
           </a:xfrm>
           <a:prstGeom prst="rect">
             <a:avLst/>
@@ -3677,7 +3735,7 @@
             <a:pPr>
               <a:defRPr b="1" sz="1800">
                 <a:solidFill>
-                  <a:srgbClr val="0F2043"/>
+                  <a:srgbClr val="00D2FF"/>
                 </a:solidFill>
                 <a:latin typeface="Segoe UI"/>
               </a:defRPr>
@@ -3690,14 +3748,14 @@
       </p:sp>
       <p:sp>
         <p:nvSpPr>
-          <p:cNvPr id="8" name="TextBox 7"/>
+          <p:cNvPr id="10" name="TextBox 9"/>
           <p:cNvSpPr txBox="1"/>
           <p:nvPr/>
         </p:nvSpPr>
         <p:spPr>
           <a:xfrm>
-            <a:off x="3657600" y="2468880"/>
-            <a:ext cx="5029200" cy="640080"/>
+            <a:off x="1188720" y="3017520"/>
+            <a:ext cx="7315200" cy="457200"/>
           </a:xfrm>
           <a:prstGeom prst="rect">
             <a:avLst/>
@@ -3713,7 +3771,7 @@
             <a:pPr>
               <a:defRPr sz="1600">
                 <a:solidFill>
-                  <a:srgbClr val="333333"/>
+                  <a:srgbClr val="AAAAB4"/>
                 </a:solidFill>
                 <a:latin typeface="Segoe UI"/>
               </a:defRPr>
@@ -3726,20 +3784,20 @@
       </p:sp>
       <p:sp>
         <p:nvSpPr>
-          <p:cNvPr id="9" name="Oval 8"/>
+          <p:cNvPr id="11" name="Oval 10"/>
           <p:cNvSpPr/>
           <p:nvPr/>
         </p:nvSpPr>
         <p:spPr>
           <a:xfrm>
-            <a:off x="457200" y="3291840"/>
-            <a:ext cx="640080" cy="640080"/>
+            <a:off x="457200" y="3657600"/>
+            <a:ext cx="548640" cy="548640"/>
           </a:xfrm>
           <a:prstGeom prst="ellipse">
             <a:avLst/>
           </a:prstGeom>
           <a:solidFill>
-            <a:srgbClr val="0072CE"/>
+            <a:srgbClr val="8A2BE2"/>
           </a:solidFill>
           <a:ln>
             <a:noFill/>
@@ -3764,9 +3822,9 @@
           <a:lstStyle/>
           <a:p>
             <a:pPr algn="ctr">
-              <a:defRPr b="1" sz="2000">
+              <a:defRPr b="1" sz="1600">
                 <a:solidFill>
-                  <a:srgbClr val="FFFFFF"/>
+                  <a:srgbClr val="F0F0F0"/>
                 </a:solidFill>
               </a:defRPr>
             </a:pPr>
@@ -3778,14 +3836,14 @@
       </p:sp>
       <p:sp>
         <p:nvSpPr>
-          <p:cNvPr id="10" name="TextBox 9"/>
+          <p:cNvPr id="12" name="TextBox 11"/>
           <p:cNvSpPr txBox="1"/>
           <p:nvPr/>
         </p:nvSpPr>
         <p:spPr>
           <a:xfrm>
-            <a:off x="1280160" y="3291840"/>
-            <a:ext cx="2286000" cy="640080"/>
+            <a:off x="1188720" y="3566160"/>
+            <a:ext cx="2743200" cy="457200"/>
           </a:xfrm>
           <a:prstGeom prst="rect">
             <a:avLst/>
@@ -3801,7 +3859,7 @@
             <a:pPr>
               <a:defRPr b="1" sz="1800">
                 <a:solidFill>
-                  <a:srgbClr val="0F2043"/>
+                  <a:srgbClr val="00D2FF"/>
                 </a:solidFill>
                 <a:latin typeface="Segoe UI"/>
               </a:defRPr>
@@ -3814,14 +3872,14 @@
       </p:sp>
       <p:sp>
         <p:nvSpPr>
-          <p:cNvPr id="11" name="TextBox 10"/>
+          <p:cNvPr id="13" name="TextBox 12"/>
           <p:cNvSpPr txBox="1"/>
           <p:nvPr/>
         </p:nvSpPr>
         <p:spPr>
           <a:xfrm>
-            <a:off x="3657600" y="3291840"/>
-            <a:ext cx="5029200" cy="640080"/>
+            <a:off x="1188720" y="3931920"/>
+            <a:ext cx="7315200" cy="457200"/>
           </a:xfrm>
           <a:prstGeom prst="rect">
             <a:avLst/>
@@ -3837,7 +3895,7 @@
             <a:pPr>
               <a:defRPr sz="1600">
                 <a:solidFill>
-                  <a:srgbClr val="333333"/>
+                  <a:srgbClr val="AAAAB4"/>
                 </a:solidFill>
                 <a:latin typeface="Segoe UI"/>
               </a:defRPr>
@@ -3850,20 +3908,20 @@
       </p:sp>
       <p:sp>
         <p:nvSpPr>
-          <p:cNvPr id="12" name="Oval 11"/>
+          <p:cNvPr id="14" name="Oval 13"/>
           <p:cNvSpPr/>
           <p:nvPr/>
         </p:nvSpPr>
         <p:spPr>
           <a:xfrm>
-            <a:off x="457200" y="4114800"/>
-            <a:ext cx="640080" cy="640080"/>
+            <a:off x="457200" y="4572000"/>
+            <a:ext cx="548640" cy="548640"/>
           </a:xfrm>
           <a:prstGeom prst="ellipse">
             <a:avLst/>
           </a:prstGeom>
           <a:solidFill>
-            <a:srgbClr val="0072CE"/>
+            <a:srgbClr val="8A2BE2"/>
           </a:solidFill>
           <a:ln>
             <a:noFill/>
@@ -3888,9 +3946,9 @@
           <a:lstStyle/>
           <a:p>
             <a:pPr algn="ctr">
-              <a:defRPr b="1" sz="2000">
+              <a:defRPr b="1" sz="1600">
                 <a:solidFill>
-                  <a:srgbClr val="FFFFFF"/>
+                  <a:srgbClr val="F0F0F0"/>
                 </a:solidFill>
               </a:defRPr>
             </a:pPr>
@@ -3902,14 +3960,14 @@
       </p:sp>
       <p:sp>
         <p:nvSpPr>
-          <p:cNvPr id="13" name="TextBox 12"/>
+          <p:cNvPr id="15" name="TextBox 14"/>
           <p:cNvSpPr txBox="1"/>
           <p:nvPr/>
         </p:nvSpPr>
         <p:spPr>
           <a:xfrm>
-            <a:off x="1280160" y="4114800"/>
-            <a:ext cx="2286000" cy="640080"/>
+            <a:off x="1188720" y="4480560"/>
+            <a:ext cx="2743200" cy="457200"/>
           </a:xfrm>
           <a:prstGeom prst="rect">
             <a:avLst/>
@@ -3925,7 +3983,7 @@
             <a:pPr>
               <a:defRPr b="1" sz="1800">
                 <a:solidFill>
-                  <a:srgbClr val="0F2043"/>
+                  <a:srgbClr val="00D2FF"/>
                 </a:solidFill>
                 <a:latin typeface="Segoe UI"/>
               </a:defRPr>
@@ -3938,14 +3996,14 @@
       </p:sp>
       <p:sp>
         <p:nvSpPr>
-          <p:cNvPr id="14" name="TextBox 13"/>
+          <p:cNvPr id="16" name="TextBox 15"/>
           <p:cNvSpPr txBox="1"/>
           <p:nvPr/>
         </p:nvSpPr>
         <p:spPr>
           <a:xfrm>
-            <a:off x="3657600" y="4114800"/>
-            <a:ext cx="5029200" cy="640080"/>
+            <a:off x="1188720" y="4846320"/>
+            <a:ext cx="7315200" cy="457200"/>
           </a:xfrm>
           <a:prstGeom prst="rect">
             <a:avLst/>
@@ -3961,7 +4019,7 @@
             <a:pPr>
               <a:defRPr sz="1600">
                 <a:solidFill>
-                  <a:srgbClr val="333333"/>
+                  <a:srgbClr val="AAAAB4"/>
                 </a:solidFill>
                 <a:latin typeface="Segoe UI"/>
               </a:defRPr>
@@ -3974,20 +4032,20 @@
       </p:sp>
       <p:sp>
         <p:nvSpPr>
-          <p:cNvPr id="15" name="Oval 14"/>
+          <p:cNvPr id="17" name="Oval 16"/>
           <p:cNvSpPr/>
           <p:nvPr/>
         </p:nvSpPr>
         <p:spPr>
           <a:xfrm>
-            <a:off x="457200" y="4937760"/>
-            <a:ext cx="640080" cy="640080"/>
+            <a:off x="457200" y="5486400"/>
+            <a:ext cx="548640" cy="548640"/>
           </a:xfrm>
           <a:prstGeom prst="ellipse">
             <a:avLst/>
           </a:prstGeom>
           <a:solidFill>
-            <a:srgbClr val="0072CE"/>
+            <a:srgbClr val="8A2BE2"/>
           </a:solidFill>
           <a:ln>
             <a:noFill/>
@@ -4012,9 +4070,9 @@
           <a:lstStyle/>
           <a:p>
             <a:pPr algn="ctr">
-              <a:defRPr b="1" sz="2000">
+              <a:defRPr b="1" sz="1600">
                 <a:solidFill>
-                  <a:srgbClr val="FFFFFF"/>
+                  <a:srgbClr val="F0F0F0"/>
                 </a:solidFill>
               </a:defRPr>
             </a:pPr>
@@ -4026,14 +4084,14 @@
       </p:sp>
       <p:sp>
         <p:nvSpPr>
-          <p:cNvPr id="16" name="TextBox 15"/>
+          <p:cNvPr id="18" name="TextBox 17"/>
           <p:cNvSpPr txBox="1"/>
           <p:nvPr/>
         </p:nvSpPr>
         <p:spPr>
           <a:xfrm>
-            <a:off x="1280160" y="4937760"/>
-            <a:ext cx="2286000" cy="640080"/>
+            <a:off x="1188720" y="5394960"/>
+            <a:ext cx="2743200" cy="457200"/>
           </a:xfrm>
           <a:prstGeom prst="rect">
             <a:avLst/>
@@ -4049,7 +4107,7 @@
             <a:pPr>
               <a:defRPr b="1" sz="1800">
                 <a:solidFill>
-                  <a:srgbClr val="0F2043"/>
+                  <a:srgbClr val="00D2FF"/>
                 </a:solidFill>
                 <a:latin typeface="Segoe UI"/>
               </a:defRPr>
@@ -4062,14 +4120,14 @@
       </p:sp>
       <p:sp>
         <p:nvSpPr>
-          <p:cNvPr id="17" name="TextBox 16"/>
+          <p:cNvPr id="19" name="TextBox 18"/>
           <p:cNvSpPr txBox="1"/>
           <p:nvPr/>
         </p:nvSpPr>
         <p:spPr>
           <a:xfrm>
-            <a:off x="3657600" y="4937760"/>
-            <a:ext cx="5029200" cy="640080"/>
+            <a:off x="1188720" y="5760720"/>
+            <a:ext cx="7315200" cy="457200"/>
           </a:xfrm>
           <a:prstGeom prst="rect">
             <a:avLst/>
@@ -4085,7 +4143,7 @@
             <a:pPr>
               <a:defRPr sz="1600">
                 <a:solidFill>
-                  <a:srgbClr val="333333"/>
+                  <a:srgbClr val="AAAAB4"/>
                 </a:solidFill>
                 <a:latin typeface="Segoe UI"/>
               </a:defRPr>
@@ -4107,14 +4165,6 @@
 <file path=ppt/slides/slide3.xml><?xml version="1.0" encoding="utf-8"?>
 <p:sld xmlns:a="http://schemas.openxmlformats.org/drawingml/2006/main" xmlns:p="http://schemas.openxmlformats.org/presentationml/2006/main" xmlns:r="http://schemas.openxmlformats.org/officeDocument/2006/relationships">
   <p:cSld>
-    <p:bg>
-      <p:bgPr>
-        <a:solidFill>
-          <a:srgbClr val="0F2043"/>
-        </a:solidFill>
-        <a:effectLst/>
-      </p:bgPr>
-    </p:bg>
     <p:spTree>
       <p:nvGrpSpPr>
         <p:cNvPr id="1" name=""/>
@@ -4122,16 +4172,40 @@
         <p:nvPr/>
       </p:nvGrpSpPr>
       <p:grpSpPr/>
-      <p:sp>
-        <p:nvSpPr>
-          <p:cNvPr id="2" name="TextBox 1"/>
+      <p:pic>
+        <p:nvPicPr>
+          <p:cNvPr id="2" name="Picture 1" descr="dark_bg.jpg"/>
+          <p:cNvPicPr>
+            <a:picLocks noChangeAspect="1"/>
+          </p:cNvPicPr>
+          <p:nvPr/>
+        </p:nvPicPr>
+        <p:blipFill>
+          <a:blip r:embed="rId2"/>
+          <a:stretch>
+            <a:fillRect/>
+          </a:stretch>
+        </p:blipFill>
+        <p:spPr>
+          <a:xfrm>
+            <a:off x="0" y="0"/>
+            <a:ext cx="9144000" cy="6858000"/>
+          </a:xfrm>
+          <a:prstGeom prst="rect">
+            <a:avLst/>
+          </a:prstGeom>
+        </p:spPr>
+      </p:pic>
+      <p:sp>
+        <p:nvSpPr>
+          <p:cNvPr id="3" name="TextBox 2"/>
           <p:cNvSpPr txBox="1"/>
           <p:nvPr/>
         </p:nvSpPr>
         <p:spPr>
           <a:xfrm>
-            <a:off x="914400" y="731520"/>
-            <a:ext cx="7315200" cy="914400"/>
+            <a:off x="457200" y="457200"/>
+            <a:ext cx="8229600" cy="914400"/>
           </a:xfrm>
           <a:prstGeom prst="rect">
             <a:avLst/>
@@ -4145,9 +4219,9 @@
           <a:lstStyle/>
           <a:p>
             <a:pPr algn="ctr">
-              <a:defRPr b="1" sz="3600">
+              <a:defRPr b="1" sz="3800">
                 <a:solidFill>
-                  <a:srgbClr val="FFFFFF"/>
+                  <a:srgbClr val="F0F0F0"/>
                 </a:solidFill>
                 <a:latin typeface="Segoe UI"/>
               </a:defRPr>
@@ -4160,20 +4234,20 @@
       </p:sp>
       <p:sp>
         <p:nvSpPr>
-          <p:cNvPr id="3" name="Rounded Rectangle 2"/>
+          <p:cNvPr id="4" name="Rectangle 3"/>
           <p:cNvSpPr/>
           <p:nvPr/>
         </p:nvSpPr>
         <p:spPr>
           <a:xfrm>
-            <a:off x="914400" y="2286000"/>
-            <a:ext cx="2286000" cy="3200400"/>
-          </a:xfrm>
-          <a:prstGeom prst="roundRect">
+            <a:off x="3200400" y="1188720"/>
+            <a:ext cx="2743200" cy="45720"/>
+          </a:xfrm>
+          <a:prstGeom prst="rect">
             <a:avLst/>
           </a:prstGeom>
           <a:solidFill>
-            <a:srgbClr val="FFFFFF"/>
+            <a:srgbClr val="8A2BE2"/>
           </a:solidFill>
           <a:ln>
             <a:noFill/>
@@ -4203,23 +4277,25 @@
       </p:sp>
       <p:sp>
         <p:nvSpPr>
-          <p:cNvPr id="4" name="Rectangle 3"/>
+          <p:cNvPr id="5" name="Rounded Rectangle 4"/>
           <p:cNvSpPr/>
           <p:nvPr/>
         </p:nvSpPr>
         <p:spPr>
           <a:xfrm>
-            <a:off x="914400" y="2286000"/>
-            <a:ext cx="2286000" cy="182880"/>
-          </a:xfrm>
-          <a:prstGeom prst="rect">
+            <a:off x="731520" y="2011680"/>
+            <a:ext cx="2377440" cy="3657600"/>
+          </a:xfrm>
+          <a:prstGeom prst="roundRect">
             <a:avLst/>
           </a:prstGeom>
           <a:solidFill>
-            <a:srgbClr val="00B2A9"/>
+            <a:srgbClr val="141419"/>
           </a:solidFill>
           <a:ln>
-            <a:noFill/>
+            <a:solidFill>
+              <a:srgbClr val="00D2FF"/>
+            </a:solidFill>
           </a:ln>
         </p:spPr>
         <p:style>
@@ -4246,14 +4322,14 @@
       </p:sp>
       <p:sp>
         <p:nvSpPr>
-          <p:cNvPr id="5" name="TextBox 4"/>
+          <p:cNvPr id="6" name="TextBox 5"/>
           <p:cNvSpPr txBox="1"/>
           <p:nvPr/>
         </p:nvSpPr>
         <p:spPr>
           <a:xfrm>
-            <a:off x="914400" y="2743200"/>
-            <a:ext cx="2286000" cy="914400"/>
+            <a:off x="731520" y="2286000"/>
+            <a:ext cx="2377440" cy="914400"/>
           </a:xfrm>
           <a:prstGeom prst="rect">
             <a:avLst/>
@@ -4267,9 +4343,9 @@
           <a:lstStyle/>
           <a:p>
             <a:pPr algn="ctr">
-              <a:defRPr b="1" sz="4000">
+              <a:defRPr b="1" sz="4800">
                 <a:solidFill>
-                  <a:srgbClr val="DCE1EB"/>
+                  <a:srgbClr val="8A2BE2"/>
                 </a:solidFill>
                 <a:latin typeface="Segoe UI"/>
               </a:defRPr>
@@ -4282,14 +4358,14 @@
       </p:sp>
       <p:sp>
         <p:nvSpPr>
-          <p:cNvPr id="6" name="TextBox 5"/>
+          <p:cNvPr id="7" name="TextBox 6"/>
           <p:cNvSpPr txBox="1"/>
           <p:nvPr/>
         </p:nvSpPr>
         <p:spPr>
           <a:xfrm>
-            <a:off x="1005840" y="3657600"/>
-            <a:ext cx="2103120" cy="1371600"/>
+            <a:off x="822960" y="3657600"/>
+            <a:ext cx="2194560" cy="1371600"/>
           </a:xfrm>
           <a:prstGeom prst="rect">
             <a:avLst/>
@@ -4303,38 +4379,44 @@
           <a:lstStyle/>
           <a:p>
             <a:pPr algn="ctr">
-              <a:defRPr b="1" sz="2000">
+              <a:defRPr b="1" sz="2200">
                 <a:solidFill>
-                  <a:srgbClr val="0F2043"/>
+                  <a:srgbClr val="F0F0F0"/>
                 </a:solidFill>
                 <a:latin typeface="Segoe UI"/>
               </a:defRPr>
             </a:pPr>
             <a:r>
-              <a:t>Arquitectura de Datos Saneada</a:t>
-            </a:r>
-          </a:p>
-        </p:txBody>
-      </p:sp>
-      <p:sp>
-        <p:nvSpPr>
-          <p:cNvPr id="7" name="Rounded Rectangle 6"/>
+              <a:t>Arquitectura de</a:t>
+            </a:r>
+            <a:br/>
+            <a:r>
+              <a:t>Datos Saneada</a:t>
+            </a:r>
+          </a:p>
+        </p:txBody>
+      </p:sp>
+      <p:sp>
+        <p:nvSpPr>
+          <p:cNvPr id="8" name="Rounded Rectangle 7"/>
           <p:cNvSpPr/>
           <p:nvPr/>
         </p:nvSpPr>
         <p:spPr>
           <a:xfrm>
-            <a:off x="3657600" y="2286000"/>
-            <a:ext cx="2286000" cy="3200400"/>
+            <a:off x="3657600" y="2011680"/>
+            <a:ext cx="2377440" cy="3657600"/>
           </a:xfrm>
           <a:prstGeom prst="roundRect">
             <a:avLst/>
           </a:prstGeom>
           <a:solidFill>
-            <a:srgbClr val="FFFFFF"/>
+            <a:srgbClr val="141419"/>
           </a:solidFill>
           <a:ln>
-            <a:noFill/>
+            <a:solidFill>
+              <a:srgbClr val="00D2FF"/>
+            </a:solidFill>
           </a:ln>
         </p:spPr>
         <p:style>
@@ -4361,23 +4443,101 @@
       </p:sp>
       <p:sp>
         <p:nvSpPr>
-          <p:cNvPr id="8" name="Rectangle 7"/>
-          <p:cNvSpPr/>
+          <p:cNvPr id="9" name="TextBox 8"/>
+          <p:cNvSpPr txBox="1"/>
           <p:nvPr/>
         </p:nvSpPr>
         <p:spPr>
           <a:xfrm>
             <a:off x="3657600" y="2286000"/>
-            <a:ext cx="2286000" cy="182880"/>
+            <a:ext cx="2377440" cy="914400"/>
           </a:xfrm>
           <a:prstGeom prst="rect">
             <a:avLst/>
           </a:prstGeom>
+          <a:noFill/>
+        </p:spPr>
+        <p:txBody>
+          <a:bodyPr wrap="none">
+            <a:spAutoFit/>
+          </a:bodyPr>
+          <a:lstStyle/>
+          <a:p>
+            <a:pPr algn="ctr">
+              <a:defRPr b="1" sz="4800">
+                <a:solidFill>
+                  <a:srgbClr val="8A2BE2"/>
+                </a:solidFill>
+                <a:latin typeface="Segoe UI"/>
+              </a:defRPr>
+            </a:pPr>
+            <a:r>
+              <a:t>02</a:t>
+            </a:r>
+          </a:p>
+        </p:txBody>
+      </p:sp>
+      <p:sp>
+        <p:nvSpPr>
+          <p:cNvPr id="10" name="TextBox 9"/>
+          <p:cNvSpPr txBox="1"/>
+          <p:nvPr/>
+        </p:nvSpPr>
+        <p:spPr>
+          <a:xfrm>
+            <a:off x="3749039" y="3657600"/>
+            <a:ext cx="2194560" cy="1371600"/>
+          </a:xfrm>
+          <a:prstGeom prst="rect">
+            <a:avLst/>
+          </a:prstGeom>
+          <a:noFill/>
+        </p:spPr>
+        <p:txBody>
+          <a:bodyPr wrap="square">
+            <a:spAutoFit/>
+          </a:bodyPr>
+          <a:lstStyle/>
+          <a:p>
+            <a:pPr algn="ctr">
+              <a:defRPr b="1" sz="2200">
+                <a:solidFill>
+                  <a:srgbClr val="F0F0F0"/>
+                </a:solidFill>
+                <a:latin typeface="Segoe UI"/>
+              </a:defRPr>
+            </a:pPr>
+            <a:r>
+              <a:t>Motor de KPIs</a:t>
+            </a:r>
+            <a:br/>
+            <a:r>
+              <a:t>Operativos</a:t>
+            </a:r>
+          </a:p>
+        </p:txBody>
+      </p:sp>
+      <p:sp>
+        <p:nvSpPr>
+          <p:cNvPr id="11" name="Rounded Rectangle 10"/>
+          <p:cNvSpPr/>
+          <p:nvPr/>
+        </p:nvSpPr>
+        <p:spPr>
+          <a:xfrm>
+            <a:off x="6583680" y="2011680"/>
+            <a:ext cx="2377440" cy="3657600"/>
+          </a:xfrm>
+          <a:prstGeom prst="roundRect">
+            <a:avLst/>
+          </a:prstGeom>
           <a:solidFill>
-            <a:srgbClr val="00B2A9"/>
+            <a:srgbClr val="141419"/>
           </a:solidFill>
           <a:ln>
-            <a:noFill/>
+            <a:solidFill>
+              <a:srgbClr val="00D2FF"/>
+            </a:solidFill>
           </a:ln>
         </p:spPr>
         <p:style>
@@ -4404,14 +4564,14 @@
       </p:sp>
       <p:sp>
         <p:nvSpPr>
-          <p:cNvPr id="9" name="TextBox 8"/>
+          <p:cNvPr id="12" name="TextBox 11"/>
           <p:cNvSpPr txBox="1"/>
           <p:nvPr/>
         </p:nvSpPr>
         <p:spPr>
           <a:xfrm>
-            <a:off x="3657600" y="2743200"/>
-            <a:ext cx="2286000" cy="914400"/>
+            <a:off x="6583680" y="2286000"/>
+            <a:ext cx="2377440" cy="914400"/>
           </a:xfrm>
           <a:prstGeom prst="rect">
             <a:avLst/>
@@ -4425,29 +4585,29 @@
           <a:lstStyle/>
           <a:p>
             <a:pPr algn="ctr">
-              <a:defRPr b="1" sz="4000">
+              <a:defRPr b="1" sz="4800">
                 <a:solidFill>
-                  <a:srgbClr val="DCE1EB"/>
+                  <a:srgbClr val="8A2BE2"/>
                 </a:solidFill>
                 <a:latin typeface="Segoe UI"/>
               </a:defRPr>
             </a:pPr>
             <a:r>
-              <a:t>02</a:t>
-            </a:r>
-          </a:p>
-        </p:txBody>
-      </p:sp>
-      <p:sp>
-        <p:nvSpPr>
-          <p:cNvPr id="10" name="TextBox 9"/>
+              <a:t>03</a:t>
+            </a:r>
+          </a:p>
+        </p:txBody>
+      </p:sp>
+      <p:sp>
+        <p:nvSpPr>
+          <p:cNvPr id="13" name="TextBox 12"/>
           <p:cNvSpPr txBox="1"/>
           <p:nvPr/>
         </p:nvSpPr>
         <p:spPr>
           <a:xfrm>
-            <a:off x="3749039" y="3657600"/>
-            <a:ext cx="2103120" cy="1371600"/>
+            <a:off x="6675120" y="3657600"/>
+            <a:ext cx="2194560" cy="1371600"/>
           </a:xfrm>
           <a:prstGeom prst="rect">
             <a:avLst/>
@@ -4461,173 +4621,19 @@
           <a:lstStyle/>
           <a:p>
             <a:pPr algn="ctr">
-              <a:defRPr b="1" sz="2000">
+              <a:defRPr b="1" sz="2200">
                 <a:solidFill>
-                  <a:srgbClr val="0F2043"/>
+                  <a:srgbClr val="F0F0F0"/>
                 </a:solidFill>
                 <a:latin typeface="Segoe UI"/>
               </a:defRPr>
             </a:pPr>
             <a:r>
-              <a:t>Motor de KPIs Operativos</a:t>
-            </a:r>
-          </a:p>
-        </p:txBody>
-      </p:sp>
-      <p:sp>
-        <p:nvSpPr>
-          <p:cNvPr id="11" name="Rounded Rectangle 10"/>
-          <p:cNvSpPr/>
-          <p:nvPr/>
-        </p:nvSpPr>
-        <p:spPr>
-          <a:xfrm>
-            <a:off x="6400800" y="2286000"/>
-            <a:ext cx="2286000" cy="3200400"/>
-          </a:xfrm>
-          <a:prstGeom prst="roundRect">
-            <a:avLst/>
-          </a:prstGeom>
-          <a:solidFill>
-            <a:srgbClr val="FFFFFF"/>
-          </a:solidFill>
-          <a:ln>
-            <a:noFill/>
-          </a:ln>
-        </p:spPr>
-        <p:style>
-          <a:lnRef idx="1">
-            <a:schemeClr val="accent1"/>
-          </a:lnRef>
-          <a:fillRef idx="3">
-            <a:schemeClr val="accent1"/>
-          </a:fillRef>
-          <a:effectRef idx="2">
-            <a:schemeClr val="accent1"/>
-          </a:effectRef>
-          <a:fontRef idx="minor">
-            <a:schemeClr val="lt1"/>
-          </a:fontRef>
-        </p:style>
-        <p:txBody>
-          <a:bodyPr rtlCol="0" anchor="ctr"/>
-          <a:lstStyle/>
-          <a:p>
-            <a:pPr algn="ctr"/>
-          </a:p>
-        </p:txBody>
-      </p:sp>
-      <p:sp>
-        <p:nvSpPr>
-          <p:cNvPr id="12" name="Rectangle 11"/>
-          <p:cNvSpPr/>
-          <p:nvPr/>
-        </p:nvSpPr>
-        <p:spPr>
-          <a:xfrm>
-            <a:off x="6400800" y="2286000"/>
-            <a:ext cx="2286000" cy="182880"/>
-          </a:xfrm>
-          <a:prstGeom prst="rect">
-            <a:avLst/>
-          </a:prstGeom>
-          <a:solidFill>
-            <a:srgbClr val="00B2A9"/>
-          </a:solidFill>
-          <a:ln>
-            <a:noFill/>
-          </a:ln>
-        </p:spPr>
-        <p:style>
-          <a:lnRef idx="1">
-            <a:schemeClr val="accent1"/>
-          </a:lnRef>
-          <a:fillRef idx="3">
-            <a:schemeClr val="accent1"/>
-          </a:fillRef>
-          <a:effectRef idx="2">
-            <a:schemeClr val="accent1"/>
-          </a:effectRef>
-          <a:fontRef idx="minor">
-            <a:schemeClr val="lt1"/>
-          </a:fontRef>
-        </p:style>
-        <p:txBody>
-          <a:bodyPr rtlCol="0" anchor="ctr"/>
-          <a:lstStyle/>
-          <a:p>
-            <a:pPr algn="ctr"/>
-          </a:p>
-        </p:txBody>
-      </p:sp>
-      <p:sp>
-        <p:nvSpPr>
-          <p:cNvPr id="13" name="TextBox 12"/>
-          <p:cNvSpPr txBox="1"/>
-          <p:nvPr/>
-        </p:nvSpPr>
-        <p:spPr>
-          <a:xfrm>
-            <a:off x="6400800" y="2743200"/>
-            <a:ext cx="2286000" cy="914400"/>
-          </a:xfrm>
-          <a:prstGeom prst="rect">
-            <a:avLst/>
-          </a:prstGeom>
-          <a:noFill/>
-        </p:spPr>
-        <p:txBody>
-          <a:bodyPr wrap="none">
-            <a:spAutoFit/>
-          </a:bodyPr>
-          <a:lstStyle/>
-          <a:p>
-            <a:pPr algn="ctr">
-              <a:defRPr b="1" sz="4000">
-                <a:solidFill>
-                  <a:srgbClr val="DCE1EB"/>
-                </a:solidFill>
-                <a:latin typeface="Segoe UI"/>
-              </a:defRPr>
-            </a:pPr>
-            <a:r>
-              <a:t>03</a:t>
-            </a:r>
-          </a:p>
-        </p:txBody>
-      </p:sp>
-      <p:sp>
-        <p:nvSpPr>
-          <p:cNvPr id="14" name="TextBox 13"/>
-          <p:cNvSpPr txBox="1"/>
-          <p:nvPr/>
-        </p:nvSpPr>
-        <p:spPr>
-          <a:xfrm>
-            <a:off x="6492240" y="3657600"/>
-            <a:ext cx="2103120" cy="1371600"/>
-          </a:xfrm>
-          <a:prstGeom prst="rect">
-            <a:avLst/>
-          </a:prstGeom>
-          <a:noFill/>
-        </p:spPr>
-        <p:txBody>
-          <a:bodyPr wrap="square">
-            <a:spAutoFit/>
-          </a:bodyPr>
-          <a:lstStyle/>
-          <a:p>
-            <a:pPr algn="ctr">
-              <a:defRPr b="1" sz="2000">
-                <a:solidFill>
-                  <a:srgbClr val="0F2043"/>
-                </a:solidFill>
-                <a:latin typeface="Segoe UI"/>
-              </a:defRPr>
-            </a:pPr>
-            <a:r>
-              <a:t>Viabilidad Financiera Demostrada</a:t>
+              <a:t>Viabilidad Financiera</a:t>
+            </a:r>
+            <a:br/>
+            <a:r>
+              <a:t>Demostrada</a:t>
             </a:r>
           </a:p>
         </p:txBody>

</xml_diff>

<commit_message>
Update BI presentation to serious dark palette and background
Co-authored-by: Loren292 <250579185+Loren292@users.noreply.github.com>
</commit_message>
<xml_diff>
--- a/Presentacion_BI.pptx
+++ b/Presentacion_BI.pptx
@@ -3092,7 +3092,7 @@
       <p:grpSpPr/>
       <p:pic>
         <p:nvPicPr>
-          <p:cNvPr id="2" name="Picture 1" descr="dark_bg.jpg"/>
+          <p:cNvPr id="2" name="Picture 1" descr="serious_bg.jpg"/>
           <p:cNvPicPr>
             <a:picLocks noChangeAspect="1"/>
           </p:cNvPicPr>
@@ -3139,7 +3139,7 @@
             <a:pPr>
               <a:defRPr sz="2200" b="1">
                 <a:solidFill>
-                  <a:srgbClr val="00D2FF"/>
+                  <a:srgbClr val="F5F5F5"/>
                 </a:solidFill>
                 <a:latin typeface="Segoe UI"/>
               </a:defRPr>
@@ -3165,11 +3165,11 @@
             <a:avLst/>
           </a:prstGeom>
           <a:solidFill>
-            <a:srgbClr val="141419"/>
+            <a:srgbClr val="1E1E23"/>
           </a:solidFill>
           <a:ln>
             <a:solidFill>
-              <a:srgbClr val="AAAAB4"/>
+              <a:srgbClr val="64646E"/>
             </a:solidFill>
           </a:ln>
         </p:spPr>
@@ -3194,7 +3194,7 @@
             <a:pPr algn="ctr">
               <a:defRPr sz="2000" b="1">
                 <a:solidFill>
-                  <a:srgbClr val="F0F0F0"/>
+                  <a:srgbClr val="B4B4BE"/>
                 </a:solidFill>
                 <a:latin typeface="Segoe UI"/>
               </a:defRPr>
@@ -3224,7 +3224,7 @@
             <a:avLst/>
           </a:prstGeom>
           <a:solidFill>
-            <a:srgbClr val="8A2BE2"/>
+            <a:srgbClr val="A0A0AA"/>
           </a:solidFill>
           <a:ln>
             <a:noFill/>
@@ -3267,11 +3267,11 @@
             <a:avLst/>
           </a:prstGeom>
           <a:solidFill>
-            <a:srgbClr val="8A2BE2"/>
+            <a:srgbClr val="A0A0AA"/>
           </a:solidFill>
           <a:ln>
             <a:solidFill>
-              <a:srgbClr val="8A2BE2"/>
+              <a:srgbClr val="A0A0AA"/>
             </a:solidFill>
           </a:ln>
         </p:spPr>
@@ -3296,7 +3296,7 @@
             <a:pPr algn="ctr">
               <a:defRPr sz="2200" b="1">
                 <a:solidFill>
-                  <a:srgbClr val="F0F0F0"/>
+                  <a:srgbClr val="141414"/>
                 </a:solidFill>
                 <a:latin typeface="Segoe UI"/>
               </a:defRPr>
@@ -3326,7 +3326,7 @@
             <a:avLst/>
           </a:prstGeom>
           <a:solidFill>
-            <a:srgbClr val="00D2FF"/>
+            <a:srgbClr val="A0A0AA"/>
           </a:solidFill>
           <a:ln>
             <a:noFill/>
@@ -3369,11 +3369,11 @@
             <a:avLst/>
           </a:prstGeom>
           <a:solidFill>
-            <a:srgbClr val="141419"/>
+            <a:srgbClr val="1E1E23"/>
           </a:solidFill>
           <a:ln>
             <a:solidFill>
-              <a:srgbClr val="00D2FF"/>
+              <a:srgbClr val="64646E"/>
             </a:solidFill>
           </a:ln>
         </p:spPr>
@@ -3398,7 +3398,7 @@
             <a:pPr algn="ctr">
               <a:defRPr sz="2000" b="1">
                 <a:solidFill>
-                  <a:srgbClr val="F0F0F0"/>
+                  <a:srgbClr val="F5F5F5"/>
                 </a:solidFill>
                 <a:latin typeface="Segoe UI"/>
               </a:defRPr>
@@ -3433,7 +3433,7 @@
       <p:grpSpPr/>
       <p:pic>
         <p:nvPicPr>
-          <p:cNvPr id="2" name="Picture 1" descr="dark_bg.jpg"/>
+          <p:cNvPr id="2" name="Picture 1" descr="serious_bg.jpg"/>
           <p:cNvPicPr>
             <a:picLocks noChangeAspect="1"/>
           </p:cNvPicPr>
@@ -3480,7 +3480,7 @@
             <a:pPr>
               <a:defRPr b="1" sz="3600">
                 <a:solidFill>
-                  <a:srgbClr val="F0F0F0"/>
+                  <a:srgbClr val="F5F5F5"/>
                 </a:solidFill>
                 <a:latin typeface="Segoe UI"/>
               </a:defRPr>
@@ -3506,7 +3506,7 @@
             <a:avLst/>
           </a:prstGeom>
           <a:solidFill>
-            <a:srgbClr val="00D2FF"/>
+            <a:srgbClr val="A0A0AA"/>
           </a:solidFill>
           <a:ln>
             <a:noFill/>
@@ -3549,10 +3549,12 @@
             <a:avLst/>
           </a:prstGeom>
           <a:solidFill>
-            <a:srgbClr val="8A2BE2"/>
+            <a:srgbClr val="1E1E23"/>
           </a:solidFill>
           <a:ln>
-            <a:noFill/>
+            <a:solidFill>
+              <a:srgbClr val="A0A0AA"/>
+            </a:solidFill>
           </a:ln>
         </p:spPr>
         <p:style>
@@ -3576,7 +3578,7 @@
             <a:pPr algn="ctr">
               <a:defRPr b="1" sz="1600">
                 <a:solidFill>
-                  <a:srgbClr val="F0F0F0"/>
+                  <a:srgbClr val="A0A0AA"/>
                 </a:solidFill>
               </a:defRPr>
             </a:pPr>
@@ -3611,7 +3613,7 @@
             <a:pPr>
               <a:defRPr b="1" sz="1800">
                 <a:solidFill>
-                  <a:srgbClr val="00D2FF"/>
+                  <a:srgbClr val="F5F5F5"/>
                 </a:solidFill>
                 <a:latin typeface="Segoe UI"/>
               </a:defRPr>
@@ -3647,7 +3649,7 @@
             <a:pPr>
               <a:defRPr sz="1600">
                 <a:solidFill>
-                  <a:srgbClr val="AAAAB4"/>
+                  <a:srgbClr val="B4B4BE"/>
                 </a:solidFill>
                 <a:latin typeface="Segoe UI"/>
               </a:defRPr>
@@ -3673,10 +3675,12 @@
             <a:avLst/>
           </a:prstGeom>
           <a:solidFill>
-            <a:srgbClr val="8A2BE2"/>
+            <a:srgbClr val="1E1E23"/>
           </a:solidFill>
           <a:ln>
-            <a:noFill/>
+            <a:solidFill>
+              <a:srgbClr val="A0A0AA"/>
+            </a:solidFill>
           </a:ln>
         </p:spPr>
         <p:style>
@@ -3700,7 +3704,7 @@
             <a:pPr algn="ctr">
               <a:defRPr b="1" sz="1600">
                 <a:solidFill>
-                  <a:srgbClr val="F0F0F0"/>
+                  <a:srgbClr val="A0A0AA"/>
                 </a:solidFill>
               </a:defRPr>
             </a:pPr>
@@ -3735,7 +3739,7 @@
             <a:pPr>
               <a:defRPr b="1" sz="1800">
                 <a:solidFill>
-                  <a:srgbClr val="00D2FF"/>
+                  <a:srgbClr val="F5F5F5"/>
                 </a:solidFill>
                 <a:latin typeface="Segoe UI"/>
               </a:defRPr>
@@ -3771,7 +3775,7 @@
             <a:pPr>
               <a:defRPr sz="1600">
                 <a:solidFill>
-                  <a:srgbClr val="AAAAB4"/>
+                  <a:srgbClr val="B4B4BE"/>
                 </a:solidFill>
                 <a:latin typeface="Segoe UI"/>
               </a:defRPr>
@@ -3797,10 +3801,12 @@
             <a:avLst/>
           </a:prstGeom>
           <a:solidFill>
-            <a:srgbClr val="8A2BE2"/>
+            <a:srgbClr val="1E1E23"/>
           </a:solidFill>
           <a:ln>
-            <a:noFill/>
+            <a:solidFill>
+              <a:srgbClr val="A0A0AA"/>
+            </a:solidFill>
           </a:ln>
         </p:spPr>
         <p:style>
@@ -3824,7 +3830,7 @@
             <a:pPr algn="ctr">
               <a:defRPr b="1" sz="1600">
                 <a:solidFill>
-                  <a:srgbClr val="F0F0F0"/>
+                  <a:srgbClr val="A0A0AA"/>
                 </a:solidFill>
               </a:defRPr>
             </a:pPr>
@@ -3859,7 +3865,7 @@
             <a:pPr>
               <a:defRPr b="1" sz="1800">
                 <a:solidFill>
-                  <a:srgbClr val="00D2FF"/>
+                  <a:srgbClr val="F5F5F5"/>
                 </a:solidFill>
                 <a:latin typeface="Segoe UI"/>
               </a:defRPr>
@@ -3895,7 +3901,7 @@
             <a:pPr>
               <a:defRPr sz="1600">
                 <a:solidFill>
-                  <a:srgbClr val="AAAAB4"/>
+                  <a:srgbClr val="B4B4BE"/>
                 </a:solidFill>
                 <a:latin typeface="Segoe UI"/>
               </a:defRPr>
@@ -3921,10 +3927,12 @@
             <a:avLst/>
           </a:prstGeom>
           <a:solidFill>
-            <a:srgbClr val="8A2BE2"/>
+            <a:srgbClr val="1E1E23"/>
           </a:solidFill>
           <a:ln>
-            <a:noFill/>
+            <a:solidFill>
+              <a:srgbClr val="A0A0AA"/>
+            </a:solidFill>
           </a:ln>
         </p:spPr>
         <p:style>
@@ -3948,7 +3956,7 @@
             <a:pPr algn="ctr">
               <a:defRPr b="1" sz="1600">
                 <a:solidFill>
-                  <a:srgbClr val="F0F0F0"/>
+                  <a:srgbClr val="A0A0AA"/>
                 </a:solidFill>
               </a:defRPr>
             </a:pPr>
@@ -3983,7 +3991,7 @@
             <a:pPr>
               <a:defRPr b="1" sz="1800">
                 <a:solidFill>
-                  <a:srgbClr val="00D2FF"/>
+                  <a:srgbClr val="F5F5F5"/>
                 </a:solidFill>
                 <a:latin typeface="Segoe UI"/>
               </a:defRPr>
@@ -4019,7 +4027,7 @@
             <a:pPr>
               <a:defRPr sz="1600">
                 <a:solidFill>
-                  <a:srgbClr val="AAAAB4"/>
+                  <a:srgbClr val="B4B4BE"/>
                 </a:solidFill>
                 <a:latin typeface="Segoe UI"/>
               </a:defRPr>
@@ -4045,10 +4053,12 @@
             <a:avLst/>
           </a:prstGeom>
           <a:solidFill>
-            <a:srgbClr val="8A2BE2"/>
+            <a:srgbClr val="1E1E23"/>
           </a:solidFill>
           <a:ln>
-            <a:noFill/>
+            <a:solidFill>
+              <a:srgbClr val="A0A0AA"/>
+            </a:solidFill>
           </a:ln>
         </p:spPr>
         <p:style>
@@ -4072,7 +4082,7 @@
             <a:pPr algn="ctr">
               <a:defRPr b="1" sz="1600">
                 <a:solidFill>
-                  <a:srgbClr val="F0F0F0"/>
+                  <a:srgbClr val="A0A0AA"/>
                 </a:solidFill>
               </a:defRPr>
             </a:pPr>
@@ -4107,7 +4117,7 @@
             <a:pPr>
               <a:defRPr b="1" sz="1800">
                 <a:solidFill>
-                  <a:srgbClr val="00D2FF"/>
+                  <a:srgbClr val="F5F5F5"/>
                 </a:solidFill>
                 <a:latin typeface="Segoe UI"/>
               </a:defRPr>
@@ -4143,7 +4153,7 @@
             <a:pPr>
               <a:defRPr sz="1600">
                 <a:solidFill>
-                  <a:srgbClr val="AAAAB4"/>
+                  <a:srgbClr val="B4B4BE"/>
                 </a:solidFill>
                 <a:latin typeface="Segoe UI"/>
               </a:defRPr>
@@ -4174,7 +4184,7 @@
       <p:grpSpPr/>
       <p:pic>
         <p:nvPicPr>
-          <p:cNvPr id="2" name="Picture 1" descr="dark_bg.jpg"/>
+          <p:cNvPr id="2" name="Picture 1" descr="serious_bg.jpg"/>
           <p:cNvPicPr>
             <a:picLocks noChangeAspect="1"/>
           </p:cNvPicPr>
@@ -4221,7 +4231,7 @@
             <a:pPr algn="ctr">
               <a:defRPr b="1" sz="3800">
                 <a:solidFill>
-                  <a:srgbClr val="F0F0F0"/>
+                  <a:srgbClr val="F5F5F5"/>
                 </a:solidFill>
                 <a:latin typeface="Segoe UI"/>
               </a:defRPr>
@@ -4247,7 +4257,7 @@
             <a:avLst/>
           </a:prstGeom>
           <a:solidFill>
-            <a:srgbClr val="8A2BE2"/>
+            <a:srgbClr val="A0A0AA"/>
           </a:solidFill>
           <a:ln>
             <a:noFill/>
@@ -4290,11 +4300,11 @@
             <a:avLst/>
           </a:prstGeom>
           <a:solidFill>
-            <a:srgbClr val="141419"/>
+            <a:srgbClr val="1E1E23"/>
           </a:solidFill>
           <a:ln>
             <a:solidFill>
-              <a:srgbClr val="00D2FF"/>
+              <a:srgbClr val="64646E"/>
             </a:solidFill>
           </a:ln>
         </p:spPr>
@@ -4345,7 +4355,7 @@
             <a:pPr algn="ctr">
               <a:defRPr b="1" sz="4800">
                 <a:solidFill>
-                  <a:srgbClr val="8A2BE2"/>
+                  <a:srgbClr val="3C3C41"/>
                 </a:solidFill>
                 <a:latin typeface="Segoe UI"/>
               </a:defRPr>
@@ -4381,7 +4391,7 @@
             <a:pPr algn="ctr">
               <a:defRPr b="1" sz="2200">
                 <a:solidFill>
-                  <a:srgbClr val="F0F0F0"/>
+                  <a:srgbClr val="F5F5F5"/>
                 </a:solidFill>
                 <a:latin typeface="Segoe UI"/>
               </a:defRPr>
@@ -4411,11 +4421,11 @@
             <a:avLst/>
           </a:prstGeom>
           <a:solidFill>
-            <a:srgbClr val="141419"/>
+            <a:srgbClr val="1E1E23"/>
           </a:solidFill>
           <a:ln>
             <a:solidFill>
-              <a:srgbClr val="00D2FF"/>
+              <a:srgbClr val="64646E"/>
             </a:solidFill>
           </a:ln>
         </p:spPr>
@@ -4466,7 +4476,7 @@
             <a:pPr algn="ctr">
               <a:defRPr b="1" sz="4800">
                 <a:solidFill>
-                  <a:srgbClr val="8A2BE2"/>
+                  <a:srgbClr val="3C3C41"/>
                 </a:solidFill>
                 <a:latin typeface="Segoe UI"/>
               </a:defRPr>
@@ -4502,7 +4512,7 @@
             <a:pPr algn="ctr">
               <a:defRPr b="1" sz="2200">
                 <a:solidFill>
-                  <a:srgbClr val="F0F0F0"/>
+                  <a:srgbClr val="F5F5F5"/>
                 </a:solidFill>
                 <a:latin typeface="Segoe UI"/>
               </a:defRPr>
@@ -4532,11 +4542,11 @@
             <a:avLst/>
           </a:prstGeom>
           <a:solidFill>
-            <a:srgbClr val="141419"/>
+            <a:srgbClr val="1E1E23"/>
           </a:solidFill>
           <a:ln>
             <a:solidFill>
-              <a:srgbClr val="00D2FF"/>
+              <a:srgbClr val="64646E"/>
             </a:solidFill>
           </a:ln>
         </p:spPr>
@@ -4587,7 +4597,7 @@
             <a:pPr algn="ctr">
               <a:defRPr b="1" sz="4800">
                 <a:solidFill>
-                  <a:srgbClr val="8A2BE2"/>
+                  <a:srgbClr val="3C3C41"/>
                 </a:solidFill>
                 <a:latin typeface="Segoe UI"/>
               </a:defRPr>
@@ -4623,7 +4633,7 @@
             <a:pPr algn="ctr">
               <a:defRPr b="1" sz="2200">
                 <a:solidFill>
-                  <a:srgbClr val="F0F0F0"/>
+                  <a:srgbClr val="F5F5F5"/>
                 </a:solidFill>
                 <a:latin typeface="Segoe UI"/>
               </a:defRPr>

</xml_diff>